<commit_message>
Broker portal claims, wordings, training and active book; admin reporting
Broker portal: the dashboard shows the active book (annual premium of active
policies, by product); new Claims (list and detail), Policy wordings and
Training pages. Document and download files are served on the portal and
admin subdomains. Admin: a Reporting page with premium in force by product
and brokerage, quoted to bound conversion and renewal retention charts.
Training decks, the broker guide PDF and the portal walkthrough are updated:
brokers now send client links themselves.

Co-Authored-By: Claude Opus 5.5 <noreply@anthropic.com>
Claude-Session: https://claude.ai/code/session_01Eh5mpih4ShNW6P8Q6cSYEM
</commit_message>
<xml_diff>
--- a/docs/training/Otta Broker Portal guide.pptx
+++ b/docs/training/Otta Broker Portal guide.pptx
@@ -24,9 +24,12 @@
     <p:sldId id="272" r:id="rId18"/>
     <p:sldId id="273" r:id="rId19"/>
     <p:sldId id="274" r:id="rId20"/>
+    <p:sldId id="275" r:id="rId21"/>
+    <p:sldId id="276" r:id="rId22"/>
+    <p:sldId id="277" r:id="rId23"/>
   </p:sldIdLst>
   <p:notesMasterIdLst>
-    <p:notesMasterId r:id="rId21"/>
+    <p:notesMasterId r:id="rId24"/>
   </p:notesMasterIdLst>
   <p:sldSz cx="12192000" cy="6858000"/>
   <p:notesSz cx="6858000" cy="12192000"/>
@@ -125,25 +128,25 @@
   <p:extLst>
     <p:ext uri="{521415D9-36F7-43E2-AB2F-B90AF26B5E84}">
       <p14:sectionLst xmlns:p14="http://schemas.microsoft.com/office/powerpoint/2010/main">
-        <p14:section name="Introduction" id="{d1eabb33-c8a3-233e-6987-885f4b5a5c6d}">
+        <p14:section name="Introduction" id="{adcffe79-76ff-bd14-767c-38b54100cc82}">
           <p14:sldIdLst>
             <p14:sldId id="257"/>
           </p14:sldIdLst>
         </p14:section>
-        <p14:section name="Signing in" id="{9c7c3d2f-c141-b441-0db7-af8fc3697d94}">
+        <p14:section name="Signing in" id="{299c6082-8414-7eed-e2bf-2b2d72798dff}">
           <p14:sldIdLst>
             <p14:sldId id="258"/>
             <p14:sldId id="259"/>
             <p14:sldId id="260"/>
           </p14:sldIdLst>
         </p14:section>
-        <p14:section name="Your dashboard" id="{36ce644a-89cb-beb2-08c8-7f0288835de8}">
+        <p14:section name="Your dashboard" id="{7fbd1039-ed23-efbe-355c-dcd25a31bab9}">
           <p14:sldIdLst>
             <p14:sldId id="261"/>
             <p14:sldId id="262"/>
           </p14:sldIdLst>
         </p14:section>
-        <p14:section name="Applying for cover" id="{5c9e63bb-886c-0f63-3db6-8f51869e922d}">
+        <p14:section name="Applying for cover" id="{8ed33386-b20b-70e0-866e-6b6504ad50d6}">
           <p14:sldIdLst>
             <p14:sldId id="263"/>
             <p14:sldId id="264"/>
@@ -153,22 +156,25 @@
             <p14:sldId id="268"/>
           </p14:sldIdLst>
         </p14:section>
-        <p14:section name="Quotes and policies" id="{719f8fe4-d5d6-66f3-da00-72ba4f0c57fa}">
+        <p14:section name="Quotes, policies and claims" id="{b8cb18e1-832b-c227-878a-69d2ffa27968}">
           <p14:sldIdLst>
             <p14:sldId id="269"/>
             <p14:sldId id="270"/>
             <p14:sldId id="271"/>
+            <p14:sldId id="272"/>
           </p14:sldIdLst>
         </p14:section>
-        <p14:section name="Help when you need it" id="{5628853b-5606-5a74-fb69-aa0fe266f8f5}">
+        <p14:section name="Wordings, training and help" id="{c8fa1ef4-81fe-9ce0-6067-9c2801020cdf}">
           <p14:sldIdLst>
-            <p14:sldId id="272"/>
             <p14:sldId id="273"/>
+            <p14:sldId id="274"/>
+            <p14:sldId id="275"/>
+            <p14:sldId id="276"/>
           </p14:sldIdLst>
         </p14:section>
-        <p14:section name="Summary" id="{45629b57-6e34-1f78-8033-29979dc6bff8}">
+        <p14:section name="Summary" id="{1bec49b5-f9a3-dd5a-d3c0-24e0259c84ed}">
           <p14:sldIdLst>
-            <p14:sldId id="274"/>
+            <p14:sldId id="277"/>
           </p14:sldIdLst>
         </p14:section>
       </p14:sectionLst>
@@ -839,7 +845,7 @@
           <a:p>
             <a:r>
               <a:rPr lang="en-US" dirty="0"/>
-              <a:t>Choose the form, then add your client's details. We email them a secure link that works for 30 days. When they submit, it comes straight to Otta and shows in your Applications. Leave the email blank to copy the link and send it yourself.</a:t>
+              <a:t>Choose the form and enter your client's name, then create the link. Copy it and send it to your client however suits you: Otta never contacts your clients. The link works for 30 days. When they submit, it comes straight to Otta and shows in your Applications.</a:t>
             </a:r>
             <a:endParaRPr lang="en-US" dirty="0"/>
           </a:p>
@@ -927,7 +933,7 @@
           <a:p>
             <a:r>
               <a:rPr lang="en-US" dirty="0"/>
-              <a:t>Applications shows everything you and your clients have sent us, and every link you've sent with its status.</a:t>
+              <a:t>Applications shows everything you and your clients have sent us, and every client link with its status.</a:t>
             </a:r>
             <a:endParaRPr lang="en-US" dirty="0"/>
           </a:p>
@@ -1015,7 +1021,7 @@
           <a:p>
             <a:r>
               <a:rPr lang="en-US" dirty="0"/>
-              <a:t>Quotes and policies. From quote to bound policy.</a:t>
+              <a:t>Quotes, policies and claims. From quote to bound policy, and following your clients' claims.</a:t>
             </a:r>
             <a:endParaRPr lang="en-US" dirty="0"/>
           </a:p>
@@ -1279,7 +1285,7 @@
           <a:p>
             <a:r>
               <a:rPr lang="en-US" dirty="0"/>
-              <a:t>Help when you need it. You talk directly to the underwriters who make the decisions.</a:t>
+              <a:t>Claims shows every claim on your clients' policies and where each one is up to. Open one to see its progress, or email the claims team about it. In an emergency, call us straight away.</a:t>
             </a:r>
             <a:endParaRPr lang="en-US" dirty="0"/>
           </a:p>
@@ -1367,7 +1373,7 @@
           <a:p>
             <a:r>
               <a:rPr lang="en-US" dirty="0"/>
-              <a:t>Help and contact lists each team's email address and our phone number. Colleagues can request their own account from the Request access page.</a:t>
+              <a:t>Wordings, training and help. Check cover, brush up on the portal, and talk directly to the underwriters who make the decisions.</a:t>
             </a:r>
             <a:endParaRPr lang="en-US" dirty="0"/>
           </a:p>
@@ -1455,7 +1461,7 @@
           <a:p>
             <a:r>
               <a:rPr lang="en-US" dirty="0"/>
-              <a:t>We're here to help. Call us on 0800 003 545. Email hello@ottainsurance.co.nz, or the team listed under Help &amp; contact. Claims: claims@ottainsurance.co.nz. Thanks for choosing Otta. We look forward to working with you.</a:t>
+              <a:t>Policy wordings has the current wording for every Otta product, so you can check cover and share it with your clients.</a:t>
             </a:r>
             <a:endParaRPr lang="en-US" dirty="0"/>
           </a:p>
@@ -1543,7 +1549,7 @@
           <a:p>
             <a:r>
               <a:rPr lang="en-US" dirty="0"/>
-              <a:t>Getting started in five steps. 1. Set your password: Use the link in your welcome email. It works for 7 days. 2. Find your way around: Your dashboard shows quotes, policies and renewals at a glance. 3. Complete or send a form: Fill it in online, or send your client a secure link. 4. Track it: See every application and quote, and bind accepted quotes. 5. Ask us anything: Help &amp; contact puts you straight through to the underwriters.</a:t>
+              <a:t>Getting started in five steps. 1. Set your password: Use the link in your welcome email. It works for 7 days. 2. Find your way around: Your dashboard shows quotes, policies and renewals at a glance. 3. Complete or share a form: Fill it in online, or send your client a secure link yourself. 4. Track it: Follow applications, quotes and claims, and bind accepted quotes. 5. Ask us anything: Help &amp; contact puts you straight through to the underwriters.</a:t>
             </a:r>
             <a:endParaRPr lang="en-US" dirty="0"/>
           </a:p>
@@ -1567,6 +1573,270 @@
             <a:fld id="{F7021451-1387-4CA6-816F-3879F97B5CBC}" type="slidenum">
               <a:rPr lang="en-US"/>
               <a:t>2</a:t>
+            </a:fld>
+            <a:endParaRPr lang="en-US"/>
+          </a:p>
+        </p:txBody>
+      </p:sp>
+    </p:spTree>
+    <p:extLst>
+      <p:ext uri="{BB962C8B-B14F-4D97-AF65-F5344CB8AC3E}">
+        <p14:creationId xmlns:p14="http://schemas.microsoft.com/office/powerpoint/2010/main" val="1024086991"/>
+      </p:ext>
+    </p:extLst>
+  </p:cSld>
+  <p:clrMapOvr>
+    <a:masterClrMapping/>
+  </p:clrMapOvr>
+</p:notes>
+</file>
+
+<file path=ppt/notesSlides/notesSlide20.xml><?xml version="1.0" encoding="utf-8"?>
+<p:notes xmlns:a="http://schemas.openxmlformats.org/drawingml/2006/main" xmlns:r="http://schemas.openxmlformats.org/officeDocument/2006/relationships" xmlns:p="http://schemas.openxmlformats.org/presentationml/2006/main">
+  <p:cSld>
+    <p:spTree>
+      <p:nvGrpSpPr>
+        <p:cNvPr id="1" name=""/>
+        <p:cNvGrpSpPr/>
+        <p:nvPr/>
+      </p:nvGrpSpPr>
+      <p:grpSpPr>
+        <a:xfrm>
+          <a:off x="0" y="0"/>
+          <a:ext cx="0" cy="0"/>
+          <a:chOff x="0" y="0"/>
+          <a:chExt cx="0" cy="0"/>
+        </a:xfrm>
+      </p:grpSpPr>
+      <p:sp>
+        <p:nvSpPr>
+          <p:cNvPr id="2" name="Slide Image Placeholder 1"/>
+          <p:cNvSpPr>
+            <a:spLocks noGrp="1" noRot="1" noChangeAspect="1"/>
+          </p:cNvSpPr>
+          <p:nvPr>
+            <p:ph type="sldImg"/>
+          </p:nvPr>
+        </p:nvSpPr>
+        <p:spPr/>
+      </p:sp>
+      <p:sp>
+        <p:nvSpPr>
+          <p:cNvPr id="3" name="Notes Placeholder 2"/>
+          <p:cNvSpPr>
+            <a:spLocks noGrp="1"/>
+          </p:cNvSpPr>
+          <p:nvPr>
+            <p:ph type="body" idx="1"/>
+          </p:nvPr>
+        </p:nvSpPr>
+        <p:spPr/>
+        <p:txBody>
+          <a:bodyPr/>
+          <a:lstStyle/>
+          <a:p>
+            <a:r>
+              <a:rPr lang="en-US" dirty="0"/>
+              <a:t>Training has this guide in the portal whenever you need it, with a walkthrough of each screen.</a:t>
+            </a:r>
+            <a:endParaRPr lang="en-US" dirty="0"/>
+          </a:p>
+        </p:txBody>
+      </p:sp>
+      <p:sp>
+        <p:nvSpPr>
+          <p:cNvPr id="4" name="Slide Number Placeholder 3"/>
+          <p:cNvSpPr>
+            <a:spLocks noGrp="1"/>
+          </p:cNvSpPr>
+          <p:nvPr>
+            <p:ph type="sldNum" sz="quarter" idx="10"/>
+          </p:nvPr>
+        </p:nvSpPr>
+        <p:spPr/>
+        <p:txBody>
+          <a:bodyPr/>
+          <a:lstStyle/>
+          <a:p>
+            <a:fld id="{F7021451-1387-4CA6-816F-3879F97B5CBC}" type="slidenum">
+              <a:rPr lang="en-US"/>
+              <a:t>20</a:t>
+            </a:fld>
+            <a:endParaRPr lang="en-US"/>
+          </a:p>
+        </p:txBody>
+      </p:sp>
+    </p:spTree>
+    <p:extLst>
+      <p:ext uri="{BB962C8B-B14F-4D97-AF65-F5344CB8AC3E}">
+        <p14:creationId xmlns:p14="http://schemas.microsoft.com/office/powerpoint/2010/main" val="1024086991"/>
+      </p:ext>
+    </p:extLst>
+  </p:cSld>
+  <p:clrMapOvr>
+    <a:masterClrMapping/>
+  </p:clrMapOvr>
+</p:notes>
+</file>
+
+<file path=ppt/notesSlides/notesSlide21.xml><?xml version="1.0" encoding="utf-8"?>
+<p:notes xmlns:a="http://schemas.openxmlformats.org/drawingml/2006/main" xmlns:r="http://schemas.openxmlformats.org/officeDocument/2006/relationships" xmlns:p="http://schemas.openxmlformats.org/presentationml/2006/main">
+  <p:cSld>
+    <p:spTree>
+      <p:nvGrpSpPr>
+        <p:cNvPr id="1" name=""/>
+        <p:cNvGrpSpPr/>
+        <p:nvPr/>
+      </p:nvGrpSpPr>
+      <p:grpSpPr>
+        <a:xfrm>
+          <a:off x="0" y="0"/>
+          <a:ext cx="0" cy="0"/>
+          <a:chOff x="0" y="0"/>
+          <a:chExt cx="0" cy="0"/>
+        </a:xfrm>
+      </p:grpSpPr>
+      <p:sp>
+        <p:nvSpPr>
+          <p:cNvPr id="2" name="Slide Image Placeholder 1"/>
+          <p:cNvSpPr>
+            <a:spLocks noGrp="1" noRot="1" noChangeAspect="1"/>
+          </p:cNvSpPr>
+          <p:nvPr>
+            <p:ph type="sldImg"/>
+          </p:nvPr>
+        </p:nvSpPr>
+        <p:spPr/>
+      </p:sp>
+      <p:sp>
+        <p:nvSpPr>
+          <p:cNvPr id="3" name="Notes Placeholder 2"/>
+          <p:cNvSpPr>
+            <a:spLocks noGrp="1"/>
+          </p:cNvSpPr>
+          <p:nvPr>
+            <p:ph type="body" idx="1"/>
+          </p:nvPr>
+        </p:nvSpPr>
+        <p:spPr/>
+        <p:txBody>
+          <a:bodyPr/>
+          <a:lstStyle/>
+          <a:p>
+            <a:r>
+              <a:rPr lang="en-US" dirty="0"/>
+              <a:t>Help and contact lists each team's email address and our phone number. Colleagues can request their own account from the Request access page.</a:t>
+            </a:r>
+            <a:endParaRPr lang="en-US" dirty="0"/>
+          </a:p>
+        </p:txBody>
+      </p:sp>
+      <p:sp>
+        <p:nvSpPr>
+          <p:cNvPr id="4" name="Slide Number Placeholder 3"/>
+          <p:cNvSpPr>
+            <a:spLocks noGrp="1"/>
+          </p:cNvSpPr>
+          <p:nvPr>
+            <p:ph type="sldNum" sz="quarter" idx="10"/>
+          </p:nvPr>
+        </p:nvSpPr>
+        <p:spPr/>
+        <p:txBody>
+          <a:bodyPr/>
+          <a:lstStyle/>
+          <a:p>
+            <a:fld id="{F7021451-1387-4CA6-816F-3879F97B5CBC}" type="slidenum">
+              <a:rPr lang="en-US"/>
+              <a:t>21</a:t>
+            </a:fld>
+            <a:endParaRPr lang="en-US"/>
+          </a:p>
+        </p:txBody>
+      </p:sp>
+    </p:spTree>
+    <p:extLst>
+      <p:ext uri="{BB962C8B-B14F-4D97-AF65-F5344CB8AC3E}">
+        <p14:creationId xmlns:p14="http://schemas.microsoft.com/office/powerpoint/2010/main" val="1024086991"/>
+      </p:ext>
+    </p:extLst>
+  </p:cSld>
+  <p:clrMapOvr>
+    <a:masterClrMapping/>
+  </p:clrMapOvr>
+</p:notes>
+</file>
+
+<file path=ppt/notesSlides/notesSlide22.xml><?xml version="1.0" encoding="utf-8"?>
+<p:notes xmlns:a="http://schemas.openxmlformats.org/drawingml/2006/main" xmlns:r="http://schemas.openxmlformats.org/officeDocument/2006/relationships" xmlns:p="http://schemas.openxmlformats.org/presentationml/2006/main">
+  <p:cSld>
+    <p:spTree>
+      <p:nvGrpSpPr>
+        <p:cNvPr id="1" name=""/>
+        <p:cNvGrpSpPr/>
+        <p:nvPr/>
+      </p:nvGrpSpPr>
+      <p:grpSpPr>
+        <a:xfrm>
+          <a:off x="0" y="0"/>
+          <a:ext cx="0" cy="0"/>
+          <a:chOff x="0" y="0"/>
+          <a:chExt cx="0" cy="0"/>
+        </a:xfrm>
+      </p:grpSpPr>
+      <p:sp>
+        <p:nvSpPr>
+          <p:cNvPr id="2" name="Slide Image Placeholder 1"/>
+          <p:cNvSpPr>
+            <a:spLocks noGrp="1" noRot="1" noChangeAspect="1"/>
+          </p:cNvSpPr>
+          <p:nvPr>
+            <p:ph type="sldImg"/>
+          </p:nvPr>
+        </p:nvSpPr>
+        <p:spPr/>
+      </p:sp>
+      <p:sp>
+        <p:nvSpPr>
+          <p:cNvPr id="3" name="Notes Placeholder 2"/>
+          <p:cNvSpPr>
+            <a:spLocks noGrp="1"/>
+          </p:cNvSpPr>
+          <p:nvPr>
+            <p:ph type="body" idx="1"/>
+          </p:nvPr>
+        </p:nvSpPr>
+        <p:spPr/>
+        <p:txBody>
+          <a:bodyPr/>
+          <a:lstStyle/>
+          <a:p>
+            <a:r>
+              <a:rPr lang="en-US" dirty="0"/>
+              <a:t>We're here to help. Call us on 0800 003 545. Email hello@ottainsurance.co.nz, or the team listed under Help &amp; contact. Claims: claims@ottainsurance.co.nz. Thanks for choosing Otta. We look forward to working with you.</a:t>
+            </a:r>
+            <a:endParaRPr lang="en-US" dirty="0"/>
+          </a:p>
+        </p:txBody>
+      </p:sp>
+      <p:sp>
+        <p:nvSpPr>
+          <p:cNvPr id="4" name="Slide Number Placeholder 3"/>
+          <p:cNvSpPr>
+            <a:spLocks noGrp="1"/>
+          </p:cNvSpPr>
+          <p:nvPr>
+            <p:ph type="sldNum" sz="quarter" idx="10"/>
+          </p:nvPr>
+        </p:nvSpPr>
+        <p:spPr/>
+        <p:txBody>
+          <a:bodyPr/>
+          <a:lstStyle/>
+          <a:p>
+            <a:fld id="{F7021451-1387-4CA6-816F-3879F97B5CBC}" type="slidenum">
+              <a:rPr lang="en-US"/>
+              <a:t>22</a:t>
             </a:fld>
             <a:endParaRPr lang="en-US"/>
           </a:p>
@@ -1983,7 +2253,7 @@
           <a:p>
             <a:r>
               <a:rPr lang="en-US" dirty="0"/>
-              <a:t>Your dashboard shows your open quote requests, active policies and renewals due in the next 60 days, with shortcuts to the forms you'll use most.</a:t>
+              <a:t>Your dashboard shows your active book with Otta, broken down by product, plus your open quote requests, active policies and renewals due in the next 60 days, with shortcuts to the forms you'll use most.</a:t>
             </a:r>
             <a:endParaRPr lang="en-US" dirty="0"/>
           </a:p>
@@ -4585,7 +4855,7 @@
                   <a:schemeClr val="tx1"/>
                 </a:solidFill>
               </a:rPr>
-              <a:t>Your client's name and email.</a:t>
+              <a:t>Choose the form, then enter your client's name.</a:t>
             </a:r>
             <a:endParaRPr lang="en-US" sz="1350" dirty="0"/>
           </a:p>
@@ -4682,104 +4952,7 @@
                   <a:schemeClr val="tx1"/>
                 </a:solidFill>
               </a:rPr>
-              <a:t>An optional note, added to the email.</a:t>
-            </a:r>
-            <a:endParaRPr lang="en-US" sz="1350" dirty="0"/>
-          </a:p>
-        </p:txBody>
-      </p:sp>
-      <p:sp>
-        <p:nvSpPr>
-          <p:cNvPr id="11" name="Step 3 marker"/>
-          <p:cNvSpPr/>
-          <p:nvPr/>
-        </p:nvSpPr>
-        <p:spPr>
-          <a:xfrm>
-            <a:off x="8503920" y="3584448"/>
-            <a:ext cx="347472" cy="347472"/>
-          </a:xfrm>
-          <a:prstGeom prst="ellipse">
-            <a:avLst/>
-          </a:prstGeom>
-          <a:solidFill>
-            <a:schemeClr val="accent3"/>
-          </a:solidFill>
-          <a:ln w="12700">
-            <a:solidFill>
-              <a:schemeClr val="accent3"/>
-            </a:solidFill>
-            <a:prstDash val="solid"/>
-          </a:ln>
-        </p:spPr>
-      </p:sp>
-      <p:sp>
-        <p:nvSpPr>
-          <p:cNvPr id="12" name="Step 3 number"/>
-          <p:cNvSpPr txBox="1"/>
-          <p:nvPr/>
-        </p:nvSpPr>
-        <p:spPr>
-          <a:xfrm>
-            <a:off x="8503920" y="3584448"/>
-            <a:ext cx="347472" cy="347472"/>
-          </a:xfrm>
-          <a:prstGeom prst="rect">
-            <a:avLst/>
-          </a:prstGeom>
-          <a:noFill/>
-          <a:ln/>
-        </p:spPr>
-        <p:txBody>
-          <a:bodyPr wrap="square" lIns="0" tIns="0" rIns="0" bIns="0" rtlCol="0" anchor="ctr"/>
-          <a:lstStyle/>
-          <a:p>
-            <a:pPr algn="ctr" indent="0" marL="0">
-              <a:buNone/>
-            </a:pPr>
-            <a:r>
-              <a:rPr lang="en-US" sz="1300" b="1" dirty="0">
-                <a:solidFill>
-                  <a:schemeClr val="bg1"/>
-                </a:solidFill>
-              </a:rPr>
-              <a:t>3</a:t>
-            </a:r>
-            <a:endParaRPr lang="en-US" sz="1300" dirty="0"/>
-          </a:p>
-        </p:txBody>
-      </p:sp>
-      <p:sp>
-        <p:nvSpPr>
-          <p:cNvPr id="13" name="Step 3 text"/>
-          <p:cNvSpPr txBox="1"/>
-          <p:nvPr/>
-        </p:nvSpPr>
-        <p:spPr>
-          <a:xfrm>
-            <a:off x="8979408" y="3566160"/>
-            <a:ext cx="2770632" cy="1115568"/>
-          </a:xfrm>
-          <a:prstGeom prst="rect">
-            <a:avLst/>
-          </a:prstGeom>
-          <a:noFill/>
-          <a:ln/>
-        </p:spPr>
-        <p:txBody>
-          <a:bodyPr wrap="square" lIns="0" tIns="0" rIns="0" bIns="0" rtlCol="0" anchor="t"/>
-          <a:lstStyle/>
-          <a:p>
-            <a:pPr indent="0" marL="0">
-              <a:buNone/>
-            </a:pPr>
-            <a:r>
-              <a:rPr lang="en-US" sz="1350" dirty="0">
-                <a:solidFill>
-                  <a:schemeClr val="tx1"/>
-                </a:solidFill>
-              </a:rPr>
-              <a:t>Create link. We email your client, and replies come back to you.</a:t>
+              <a:t>Create link, then copy it and send it to your client yourself.</a:t>
             </a:r>
             <a:endParaRPr lang="en-US" sz="1350" dirty="0"/>
           </a:p>
@@ -5137,7 +5310,7 @@
                   <a:schemeClr val="tx1"/>
                 </a:solidFill>
               </a:rPr>
-              <a:t>Links you've sent to clients, and whether they're done.</a:t>
+              <a:t>Links you've created for clients, and whether they're done.</a:t>
             </a:r>
             <a:endParaRPr lang="en-US" sz="1350" dirty="0"/>
           </a:p>
@@ -5234,7 +5407,7 @@
                   <a:schemeClr val="tx1"/>
                 </a:solidFill>
               </a:rPr>
-              <a:t>Send another form, or fill one in online.</a:t>
+              <a:t>Create another client link, or fill in a form online.</a:t>
             </a:r>
             <a:endParaRPr lang="en-US" sz="1350" dirty="0"/>
           </a:p>
@@ -5378,7 +5551,7 @@
                   <a:schemeClr val="bg1"/>
                 </a:solidFill>
               </a:rPr>
-              <a:t>Quotes and policies</a:t>
+              <a:t>Quotes, policies and claims</a:t>
             </a:r>
             <a:endParaRPr lang="en-US" sz="4000" dirty="0"/>
           </a:p>
@@ -5416,7 +5589,7 @@
                   <a:schemeClr val="bg1"/>
                 </a:solidFill>
               </a:rPr>
-              <a:t>From quote to bound policy.</a:t>
+              <a:t>From quote to bound policy, and following your clients' claims.</a:t>
             </a:r>
             <a:endParaRPr lang="en-US" sz="2000" dirty="0"/>
           </a:p>
@@ -6501,43 +6674,7 @@
       </p:grpSpPr>
       <p:sp>
         <p:nvSpPr>
-          <p:cNvPr id="2" name="Section number"/>
-          <p:cNvSpPr txBox="1"/>
-          <p:nvPr/>
-        </p:nvSpPr>
-        <p:spPr>
-          <a:xfrm>
-            <a:off x="731520" y="1463040"/>
-            <a:ext cx="1828800" cy="1097280"/>
-          </a:xfrm>
-          <a:prstGeom prst="rect">
-            <a:avLst/>
-          </a:prstGeom>
-          <a:noFill/>
-          <a:ln/>
-        </p:spPr>
-        <p:txBody>
-          <a:bodyPr wrap="square" lIns="0" tIns="0" rIns="0" bIns="0" rtlCol="0" anchor="ctr"/>
-          <a:lstStyle/>
-          <a:p>
-            <a:pPr indent="0" marL="0">
-              <a:buNone/>
-            </a:pPr>
-            <a:r>
-              <a:rPr lang="en-US" sz="6600" b="1" dirty="0">
-                <a:solidFill>
-                  <a:schemeClr val="accent2"/>
-                </a:solidFill>
-              </a:rPr>
-              <a:t>05</a:t>
-            </a:r>
-            <a:endParaRPr lang="en-US" sz="6600" dirty="0"/>
-          </a:p>
-        </p:txBody>
-      </p:sp>
-      <p:sp>
-        <p:nvSpPr>
-          <p:cNvPr id="3" name="Text 0"/>
+          <p:cNvPr id="2" name="Text 0"/>
           <p:cNvSpPr/>
           <p:nvPr>
             <p:ph idx="101" type="title" hasCustomPrompt="1"/>
@@ -6545,8 +6682,161 @@
         </p:nvSpPr>
         <p:spPr>
           <a:xfrm>
-            <a:off x="731520" y="2743200"/>
-            <a:ext cx="10058400" cy="1005840"/>
+            <a:off x="457200" y="274320"/>
+            <a:ext cx="10058400" cy="685800"/>
+          </a:xfrm>
+          <a:prstGeom prst="rect">
+            <a:avLst/>
+          </a:prstGeom>
+          <a:noFill/>
+          <a:ln/>
+        </p:spPr>
+        <p:txBody>
+          <a:bodyPr wrap="square" lIns="0" tIns="0" rIns="0" bIns="0" rtlCol="0" anchor="ctr"/>
+          <a:lstStyle/>
+          <a:p>
+            <a:pPr algn="l" indent="0" marL="0">
+              <a:buNone/>
+            </a:pPr>
+            <a:r>
+              <a:rPr lang="en-US" sz="2800" b="1" dirty="0">
+                <a:solidFill>
+                  <a:schemeClr val="tx2"/>
+                </a:solidFill>
+              </a:rPr>
+              <a:t>Following your clients' claims</a:t>
+            </a:r>
+            <a:endParaRPr lang="en-US" sz="2800" dirty="0"/>
+          </a:p>
+        </p:txBody>
+      </p:sp>
+      <p:sp>
+        <p:nvSpPr>
+          <p:cNvPr id="3" name="Screenshot frame"/>
+          <p:cNvSpPr/>
+          <p:nvPr/>
+        </p:nvSpPr>
+        <p:spPr>
+          <a:xfrm>
+            <a:off x="402336" y="1133856"/>
+            <a:ext cx="7790688" cy="4910328"/>
+          </a:xfrm>
+          <a:prstGeom prst="rect">
+            <a:avLst/>
+          </a:prstGeom>
+          <a:solidFill>
+            <a:schemeClr val="bg1"/>
+          </a:solidFill>
+          <a:ln w="12700">
+            <a:solidFill>
+              <a:srgbClr val="D5DFDD"/>
+            </a:solidFill>
+            <a:prstDash val="solid"/>
+          </a:ln>
+          <a:effectLst>
+            <a:outerShdw sx="100000" sy="100000" kx="0" ky="0" algn="bl" rotWithShape="0" blurRad="76200" dist="25400" dir="5400000">
+              <a:srgbClr val="000000">
+                <a:alpha val="12000"/>
+              </a:srgbClr>
+            </a:outerShdw>
+          </a:effectLst>
+        </p:spPr>
+      </p:sp>
+      <p:pic>
+        <p:nvPicPr>
+          <p:cNvPr id="4" name="Screenshot" descr="Following your clients' claims: screenshot with numbered callouts">    </p:cNvPr>
+          <p:cNvPicPr>
+            <a:picLocks noChangeAspect="1"/>
+          </p:cNvPicPr>
+          <p:nvPr/>
+        </p:nvPicPr>
+        <p:blipFill>
+          <a:blip r:embed="rId1"/>
+          <a:stretch>
+            <a:fillRect/>
+          </a:stretch>
+        </p:blipFill>
+        <p:spPr>
+          <a:xfrm>
+            <a:off x="457200" y="1188720"/>
+            <a:ext cx="7680960" cy="4800600"/>
+          </a:xfrm>
+          <a:prstGeom prst="rect">
+            <a:avLst/>
+          </a:prstGeom>
+        </p:spPr>
+      </p:pic>
+      <p:sp>
+        <p:nvSpPr>
+          <p:cNvPr id="5" name="Step 1 marker"/>
+          <p:cNvSpPr/>
+          <p:nvPr/>
+        </p:nvSpPr>
+        <p:spPr>
+          <a:xfrm>
+            <a:off x="8503920" y="1207008"/>
+            <a:ext cx="347472" cy="347472"/>
+          </a:xfrm>
+          <a:prstGeom prst="ellipse">
+            <a:avLst/>
+          </a:prstGeom>
+          <a:solidFill>
+            <a:schemeClr val="accent3"/>
+          </a:solidFill>
+          <a:ln w="12700">
+            <a:solidFill>
+              <a:schemeClr val="accent3"/>
+            </a:solidFill>
+            <a:prstDash val="solid"/>
+          </a:ln>
+        </p:spPr>
+      </p:sp>
+      <p:sp>
+        <p:nvSpPr>
+          <p:cNvPr id="6" name="Step 1 number"/>
+          <p:cNvSpPr txBox="1"/>
+          <p:nvPr/>
+        </p:nvSpPr>
+        <p:spPr>
+          <a:xfrm>
+            <a:off x="8503920" y="1207008"/>
+            <a:ext cx="347472" cy="347472"/>
+          </a:xfrm>
+          <a:prstGeom prst="rect">
+            <a:avLst/>
+          </a:prstGeom>
+          <a:noFill/>
+          <a:ln/>
+        </p:spPr>
+        <p:txBody>
+          <a:bodyPr wrap="square" lIns="0" tIns="0" rIns="0" bIns="0" rtlCol="0" anchor="ctr"/>
+          <a:lstStyle/>
+          <a:p>
+            <a:pPr algn="ctr" indent="0" marL="0">
+              <a:buNone/>
+            </a:pPr>
+            <a:r>
+              <a:rPr lang="en-US" sz="1300" b="1" dirty="0">
+                <a:solidFill>
+                  <a:schemeClr val="bg1"/>
+                </a:solidFill>
+              </a:rPr>
+              <a:t>1</a:t>
+            </a:r>
+            <a:endParaRPr lang="en-US" sz="1300" dirty="0"/>
+          </a:p>
+        </p:txBody>
+      </p:sp>
+      <p:sp>
+        <p:nvSpPr>
+          <p:cNvPr id="7" name="Step 1 text"/>
+          <p:cNvSpPr txBox="1"/>
+          <p:nvPr/>
+        </p:nvSpPr>
+        <p:spPr>
+          <a:xfrm>
+            <a:off x="8979408" y="1188720"/>
+            <a:ext cx="2770632" cy="1115568"/>
           </a:xfrm>
           <a:prstGeom prst="rect">
             <a:avLst/>
@@ -6558,33 +6848,189 @@
           <a:bodyPr wrap="square" lIns="0" tIns="0" rIns="0" bIns="0" rtlCol="0" anchor="t"/>
           <a:lstStyle/>
           <a:p>
-            <a:pPr algn="l" indent="0" marL="0">
-              <a:buNone/>
-            </a:pPr>
-            <a:r>
-              <a:rPr lang="en-US" sz="4000" b="1" dirty="0">
+            <a:pPr indent="0" marL="0">
+              <a:buNone/>
+            </a:pPr>
+            <a:r>
+              <a:rPr lang="en-US" sz="1350" dirty="0">
+                <a:solidFill>
+                  <a:schemeClr val="tx1"/>
+                </a:solidFill>
+              </a:rPr>
+              <a:t>Open claims, claims this year and what has been paid.</a:t>
+            </a:r>
+            <a:endParaRPr lang="en-US" sz="1350" dirty="0"/>
+          </a:p>
+        </p:txBody>
+      </p:sp>
+      <p:sp>
+        <p:nvSpPr>
+          <p:cNvPr id="8" name="Step 2 marker"/>
+          <p:cNvSpPr/>
+          <p:nvPr/>
+        </p:nvSpPr>
+        <p:spPr>
+          <a:xfrm>
+            <a:off x="8503920" y="2395728"/>
+            <a:ext cx="347472" cy="347472"/>
+          </a:xfrm>
+          <a:prstGeom prst="ellipse">
+            <a:avLst/>
+          </a:prstGeom>
+          <a:solidFill>
+            <a:schemeClr val="accent3"/>
+          </a:solidFill>
+          <a:ln w="12700">
+            <a:solidFill>
+              <a:schemeClr val="accent3"/>
+            </a:solidFill>
+            <a:prstDash val="solid"/>
+          </a:ln>
+        </p:spPr>
+      </p:sp>
+      <p:sp>
+        <p:nvSpPr>
+          <p:cNvPr id="9" name="Step 2 number"/>
+          <p:cNvSpPr txBox="1"/>
+          <p:nvPr/>
+        </p:nvSpPr>
+        <p:spPr>
+          <a:xfrm>
+            <a:off x="8503920" y="2395728"/>
+            <a:ext cx="347472" cy="347472"/>
+          </a:xfrm>
+          <a:prstGeom prst="rect">
+            <a:avLst/>
+          </a:prstGeom>
+          <a:noFill/>
+          <a:ln/>
+        </p:spPr>
+        <p:txBody>
+          <a:bodyPr wrap="square" lIns="0" tIns="0" rIns="0" bIns="0" rtlCol="0" anchor="ctr"/>
+          <a:lstStyle/>
+          <a:p>
+            <a:pPr algn="ctr" indent="0" marL="0">
+              <a:buNone/>
+            </a:pPr>
+            <a:r>
+              <a:rPr lang="en-US" sz="1300" b="1" dirty="0">
                 <a:solidFill>
                   <a:schemeClr val="bg1"/>
                 </a:solidFill>
               </a:rPr>
-              <a:t>Help when you need it</a:t>
-            </a:r>
-            <a:endParaRPr lang="en-US" sz="4000" dirty="0"/>
-          </a:p>
-        </p:txBody>
-      </p:sp>
-      <p:sp>
-        <p:nvSpPr>
-          <p:cNvPr id="4" name="Text 0"/>
+              <a:t>2</a:t>
+            </a:r>
+            <a:endParaRPr lang="en-US" sz="1300" dirty="0"/>
+          </a:p>
+        </p:txBody>
+      </p:sp>
+      <p:sp>
+        <p:nvSpPr>
+          <p:cNvPr id="10" name="Step 2 text"/>
+          <p:cNvSpPr txBox="1"/>
+          <p:nvPr/>
+        </p:nvSpPr>
+        <p:spPr>
+          <a:xfrm>
+            <a:off x="8979408" y="2377440"/>
+            <a:ext cx="2770632" cy="1115568"/>
+          </a:xfrm>
+          <a:prstGeom prst="rect">
+            <a:avLst/>
+          </a:prstGeom>
+          <a:noFill/>
+          <a:ln/>
+        </p:spPr>
+        <p:txBody>
+          <a:bodyPr wrap="square" lIns="0" tIns="0" rIns="0" bIns="0" rtlCol="0" anchor="t"/>
+          <a:lstStyle/>
+          <a:p>
+            <a:pPr indent="0" marL="0">
+              <a:buNone/>
+            </a:pPr>
+            <a:r>
+              <a:rPr lang="en-US" sz="1350" dirty="0">
+                <a:solidFill>
+                  <a:schemeClr val="tx1"/>
+                </a:solidFill>
+              </a:rPr>
+              <a:t>Each claim and where it's up to. Select one to see its progress.</a:t>
+            </a:r>
+            <a:endParaRPr lang="en-US" sz="1350" dirty="0"/>
+          </a:p>
+        </p:txBody>
+      </p:sp>
+      <p:sp>
+        <p:nvSpPr>
+          <p:cNvPr id="11" name="Step 3 marker"/>
           <p:cNvSpPr/>
-          <p:nvPr>
-            <p:ph idx="102" type="body" hasCustomPrompt="1"/>
-          </p:nvPr>
-        </p:nvSpPr>
-        <p:spPr>
-          <a:xfrm>
-            <a:off x="731520" y="3794760"/>
-            <a:ext cx="8686800" cy="1097280"/>
+          <p:nvPr/>
+        </p:nvSpPr>
+        <p:spPr>
+          <a:xfrm>
+            <a:off x="8503920" y="3584448"/>
+            <a:ext cx="347472" cy="347472"/>
+          </a:xfrm>
+          <a:prstGeom prst="ellipse">
+            <a:avLst/>
+          </a:prstGeom>
+          <a:solidFill>
+            <a:schemeClr val="accent3"/>
+          </a:solidFill>
+          <a:ln w="12700">
+            <a:solidFill>
+              <a:schemeClr val="accent3"/>
+            </a:solidFill>
+            <a:prstDash val="solid"/>
+          </a:ln>
+        </p:spPr>
+      </p:sp>
+      <p:sp>
+        <p:nvSpPr>
+          <p:cNvPr id="12" name="Step 3 number"/>
+          <p:cNvSpPr txBox="1"/>
+          <p:nvPr/>
+        </p:nvSpPr>
+        <p:spPr>
+          <a:xfrm>
+            <a:off x="8503920" y="3584448"/>
+            <a:ext cx="347472" cy="347472"/>
+          </a:xfrm>
+          <a:prstGeom prst="rect">
+            <a:avLst/>
+          </a:prstGeom>
+          <a:noFill/>
+          <a:ln/>
+        </p:spPr>
+        <p:txBody>
+          <a:bodyPr wrap="square" lIns="0" tIns="0" rIns="0" bIns="0" rtlCol="0" anchor="ctr"/>
+          <a:lstStyle/>
+          <a:p>
+            <a:pPr algn="ctr" indent="0" marL="0">
+              <a:buNone/>
+            </a:pPr>
+            <a:r>
+              <a:rPr lang="en-US" sz="1300" b="1" dirty="0">
+                <a:solidFill>
+                  <a:schemeClr val="bg1"/>
+                </a:solidFill>
+              </a:rPr>
+              <a:t>3</a:t>
+            </a:r>
+            <a:endParaRPr lang="en-US" sz="1300" dirty="0"/>
+          </a:p>
+        </p:txBody>
+      </p:sp>
+      <p:sp>
+        <p:nvSpPr>
+          <p:cNvPr id="13" name="Step 3 text"/>
+          <p:cNvSpPr txBox="1"/>
+          <p:nvPr/>
+        </p:nvSpPr>
+        <p:spPr>
+          <a:xfrm>
+            <a:off x="8979408" y="3566160"/>
+            <a:ext cx="2770632" cy="1115568"/>
           </a:xfrm>
           <a:prstGeom prst="rect">
             <a:avLst/>
@@ -6596,18 +7042,18 @@
           <a:bodyPr wrap="square" lIns="0" tIns="0" rIns="0" bIns="0" rtlCol="0" anchor="t"/>
           <a:lstStyle/>
           <a:p>
-            <a:pPr algn="l" indent="0" marL="0">
-              <a:buNone/>
-            </a:pPr>
-            <a:r>
-              <a:rPr lang="en-US" sz="2000" dirty="0">
-                <a:solidFill>
-                  <a:schemeClr val="bg1"/>
-                </a:solidFill>
-              </a:rPr>
-              <a:t>You talk directly to the underwriters who make the decisions.</a:t>
-            </a:r>
-            <a:endParaRPr lang="en-US" sz="2000" dirty="0"/>
+            <a:pPr indent="0" marL="0">
+              <a:buNone/>
+            </a:pPr>
+            <a:r>
+              <a:rPr lang="en-US" sz="1350" dirty="0">
+                <a:solidFill>
+                  <a:schemeClr val="tx1"/>
+                </a:solidFill>
+              </a:rPr>
+              <a:t>Lodge a claim with the right claim form.</a:t>
+            </a:r>
+            <a:endParaRPr lang="en-US" sz="1350" dirty="0"/>
           </a:p>
         </p:txBody>
       </p:sp>
@@ -6623,7 +7069,7 @@
         </p:nvSpPr>
         <p:spPr>
           <a:xfrm>
-            <a:off x="11155680" y="6263640"/>
+            <a:off x="11201400" y="6446520"/>
             <a:ext cx="548640" cy="274320"/>
           </a:xfrm>
           <a:prstGeom prst="rect">
@@ -6641,7 +7087,7 @@
             <a:lvl1pPr>
               <a:defRPr sz="1000">
                 <a:solidFill>
-                  <a:srgbClr val="FFFFFF"/>
+                  <a:srgbClr val="6B6E72"/>
                 </a:solidFill>
               </a:defRPr>
             </a:lvl1pPr>
@@ -6683,7 +7129,43 @@
       </p:grpSpPr>
       <p:sp>
         <p:nvSpPr>
-          <p:cNvPr id="2" name="Text 0"/>
+          <p:cNvPr id="2" name="Section number"/>
+          <p:cNvSpPr txBox="1"/>
+          <p:nvPr/>
+        </p:nvSpPr>
+        <p:spPr>
+          <a:xfrm>
+            <a:off x="731520" y="1463040"/>
+            <a:ext cx="1828800" cy="1097280"/>
+          </a:xfrm>
+          <a:prstGeom prst="rect">
+            <a:avLst/>
+          </a:prstGeom>
+          <a:noFill/>
+          <a:ln/>
+        </p:spPr>
+        <p:txBody>
+          <a:bodyPr wrap="square" lIns="0" tIns="0" rIns="0" bIns="0" rtlCol="0" anchor="ctr"/>
+          <a:lstStyle/>
+          <a:p>
+            <a:pPr indent="0" marL="0">
+              <a:buNone/>
+            </a:pPr>
+            <a:r>
+              <a:rPr lang="en-US" sz="6600" b="1" dirty="0">
+                <a:solidFill>
+                  <a:schemeClr val="accent2"/>
+                </a:solidFill>
+              </a:rPr>
+              <a:t>05</a:t>
+            </a:r>
+            <a:endParaRPr lang="en-US" sz="6600" dirty="0"/>
+          </a:p>
+        </p:txBody>
+      </p:sp>
+      <p:sp>
+        <p:nvSpPr>
+          <p:cNvPr id="3" name="Text 0"/>
           <p:cNvSpPr/>
           <p:nvPr>
             <p:ph idx="101" type="title" hasCustomPrompt="1"/>
@@ -6691,281 +7173,69 @@
         </p:nvSpPr>
         <p:spPr>
           <a:xfrm>
-            <a:off x="457200" y="274320"/>
-            <a:ext cx="10058400" cy="685800"/>
-          </a:xfrm>
-          <a:prstGeom prst="rect">
-            <a:avLst/>
-          </a:prstGeom>
-          <a:noFill/>
-          <a:ln/>
-        </p:spPr>
-        <p:txBody>
-          <a:bodyPr wrap="square" lIns="0" tIns="0" rIns="0" bIns="0" rtlCol="0" anchor="ctr"/>
+            <a:off x="731520" y="2743200"/>
+            <a:ext cx="10058400" cy="1005840"/>
+          </a:xfrm>
+          <a:prstGeom prst="rect">
+            <a:avLst/>
+          </a:prstGeom>
+          <a:noFill/>
+          <a:ln/>
+        </p:spPr>
+        <p:txBody>
+          <a:bodyPr wrap="square" lIns="0" tIns="0" rIns="0" bIns="0" rtlCol="0" anchor="t"/>
           <a:lstStyle/>
           <a:p>
             <a:pPr algn="l" indent="0" marL="0">
               <a:buNone/>
             </a:pPr>
             <a:r>
-              <a:rPr lang="en-US" sz="2800" b="1" dirty="0">
-                <a:solidFill>
-                  <a:schemeClr val="tx2"/>
-                </a:solidFill>
-              </a:rPr>
-              <a:t>Help and contact</a:t>
-            </a:r>
-            <a:endParaRPr lang="en-US" sz="2800" dirty="0"/>
-          </a:p>
-        </p:txBody>
-      </p:sp>
-      <p:sp>
-        <p:nvSpPr>
-          <p:cNvPr id="3" name="Screenshot frame"/>
+              <a:rPr lang="en-US" sz="4000" b="1" dirty="0">
+                <a:solidFill>
+                  <a:schemeClr val="bg1"/>
+                </a:solidFill>
+              </a:rPr>
+              <a:t>Wordings, training and help</a:t>
+            </a:r>
+            <a:endParaRPr lang="en-US" sz="4000" dirty="0"/>
+          </a:p>
+        </p:txBody>
+      </p:sp>
+      <p:sp>
+        <p:nvSpPr>
+          <p:cNvPr id="4" name="Text 0"/>
           <p:cNvSpPr/>
-          <p:nvPr/>
-        </p:nvSpPr>
-        <p:spPr>
-          <a:xfrm>
-            <a:off x="402336" y="1133856"/>
-            <a:ext cx="7790688" cy="4910328"/>
-          </a:xfrm>
-          <a:prstGeom prst="rect">
-            <a:avLst/>
-          </a:prstGeom>
-          <a:solidFill>
-            <a:schemeClr val="bg1"/>
-          </a:solidFill>
-          <a:ln w="12700">
-            <a:solidFill>
-              <a:srgbClr val="D5DFDD"/>
-            </a:solidFill>
-            <a:prstDash val="solid"/>
-          </a:ln>
-          <a:effectLst>
-            <a:outerShdw sx="100000" sy="100000" kx="0" ky="0" algn="bl" rotWithShape="0" blurRad="76200" dist="25400" dir="5400000">
-              <a:srgbClr val="000000">
-                <a:alpha val="12000"/>
-              </a:srgbClr>
-            </a:outerShdw>
-          </a:effectLst>
-        </p:spPr>
-      </p:sp>
-      <p:pic>
-        <p:nvPicPr>
-          <p:cNvPr id="4" name="Screenshot" descr="Help and contact: screenshot with numbered callouts">    </p:cNvPr>
-          <p:cNvPicPr>
-            <a:picLocks noChangeAspect="1"/>
-          </p:cNvPicPr>
-          <p:nvPr/>
-        </p:nvPicPr>
-        <p:blipFill>
-          <a:blip r:embed="rId1"/>
-          <a:stretch>
-            <a:fillRect/>
-          </a:stretch>
-        </p:blipFill>
-        <p:spPr>
-          <a:xfrm>
-            <a:off x="457200" y="1188720"/>
-            <a:ext cx="7680960" cy="4800600"/>
-          </a:xfrm>
-          <a:prstGeom prst="rect">
-            <a:avLst/>
-          </a:prstGeom>
-        </p:spPr>
-      </p:pic>
-      <p:sp>
-        <p:nvSpPr>
-          <p:cNvPr id="5" name="Step 1 marker"/>
-          <p:cNvSpPr/>
-          <p:nvPr/>
-        </p:nvSpPr>
-        <p:spPr>
-          <a:xfrm>
-            <a:off x="8503920" y="1207008"/>
-            <a:ext cx="347472" cy="347472"/>
-          </a:xfrm>
-          <a:prstGeom prst="ellipse">
-            <a:avLst/>
-          </a:prstGeom>
-          <a:solidFill>
-            <a:schemeClr val="accent3"/>
-          </a:solidFill>
-          <a:ln w="12700">
-            <a:solidFill>
-              <a:schemeClr val="accent3"/>
-            </a:solidFill>
-            <a:prstDash val="solid"/>
-          </a:ln>
-        </p:spPr>
-      </p:sp>
-      <p:sp>
-        <p:nvSpPr>
-          <p:cNvPr id="6" name="Step 1 number"/>
-          <p:cNvSpPr txBox="1"/>
-          <p:nvPr/>
-        </p:nvSpPr>
-        <p:spPr>
-          <a:xfrm>
-            <a:off x="8503920" y="1207008"/>
-            <a:ext cx="347472" cy="347472"/>
-          </a:xfrm>
-          <a:prstGeom prst="rect">
-            <a:avLst/>
-          </a:prstGeom>
-          <a:noFill/>
-          <a:ln/>
-        </p:spPr>
-        <p:txBody>
-          <a:bodyPr wrap="square" lIns="0" tIns="0" rIns="0" bIns="0" rtlCol="0" anchor="ctr"/>
-          <a:lstStyle/>
-          <a:p>
-            <a:pPr algn="ctr" indent="0" marL="0">
-              <a:buNone/>
-            </a:pPr>
-            <a:r>
-              <a:rPr lang="en-US" sz="1300" b="1" dirty="0">
+          <p:nvPr>
+            <p:ph idx="102" type="body" hasCustomPrompt="1"/>
+          </p:nvPr>
+        </p:nvSpPr>
+        <p:spPr>
+          <a:xfrm>
+            <a:off x="731520" y="3794760"/>
+            <a:ext cx="8686800" cy="1097280"/>
+          </a:xfrm>
+          <a:prstGeom prst="rect">
+            <a:avLst/>
+          </a:prstGeom>
+          <a:noFill/>
+          <a:ln/>
+        </p:spPr>
+        <p:txBody>
+          <a:bodyPr wrap="square" lIns="0" tIns="0" rIns="0" bIns="0" rtlCol="0" anchor="t"/>
+          <a:lstStyle/>
+          <a:p>
+            <a:pPr algn="l" indent="0" marL="0">
+              <a:buNone/>
+            </a:pPr>
+            <a:r>
+              <a:rPr lang="en-US" sz="2000" dirty="0">
                 <a:solidFill>
                   <a:schemeClr val="bg1"/>
                 </a:solidFill>
               </a:rPr>
-              <a:t>1</a:t>
-            </a:r>
-            <a:endParaRPr lang="en-US" sz="1300" dirty="0"/>
-          </a:p>
-        </p:txBody>
-      </p:sp>
-      <p:sp>
-        <p:nvSpPr>
-          <p:cNvPr id="7" name="Step 1 text"/>
-          <p:cNvSpPr txBox="1"/>
-          <p:nvPr/>
-        </p:nvSpPr>
-        <p:spPr>
-          <a:xfrm>
-            <a:off x="8979408" y="1188720"/>
-            <a:ext cx="2770632" cy="1115568"/>
-          </a:xfrm>
-          <a:prstGeom prst="rect">
-            <a:avLst/>
-          </a:prstGeom>
-          <a:noFill/>
-          <a:ln/>
-        </p:spPr>
-        <p:txBody>
-          <a:bodyPr wrap="square" lIns="0" tIns="0" rIns="0" bIns="0" rtlCol="0" anchor="t"/>
-          <a:lstStyle/>
-          <a:p>
-            <a:pPr indent="0" marL="0">
-              <a:buNone/>
-            </a:pPr>
-            <a:r>
-              <a:rPr lang="en-US" sz="1350" dirty="0">
-                <a:solidFill>
-                  <a:schemeClr val="tx1"/>
-                </a:solidFill>
-              </a:rPr>
-              <a:t>Email the right team directly.</a:t>
-            </a:r>
-            <a:endParaRPr lang="en-US" sz="1350" dirty="0"/>
-          </a:p>
-        </p:txBody>
-      </p:sp>
-      <p:sp>
-        <p:nvSpPr>
-          <p:cNvPr id="8" name="Step 2 marker"/>
-          <p:cNvSpPr/>
-          <p:nvPr/>
-        </p:nvSpPr>
-        <p:spPr>
-          <a:xfrm>
-            <a:off x="8503920" y="2395728"/>
-            <a:ext cx="347472" cy="347472"/>
-          </a:xfrm>
-          <a:prstGeom prst="ellipse">
-            <a:avLst/>
-          </a:prstGeom>
-          <a:solidFill>
-            <a:schemeClr val="accent3"/>
-          </a:solidFill>
-          <a:ln w="12700">
-            <a:solidFill>
-              <a:schemeClr val="accent3"/>
-            </a:solidFill>
-            <a:prstDash val="solid"/>
-          </a:ln>
-        </p:spPr>
-      </p:sp>
-      <p:sp>
-        <p:nvSpPr>
-          <p:cNvPr id="9" name="Step 2 number"/>
-          <p:cNvSpPr txBox="1"/>
-          <p:nvPr/>
-        </p:nvSpPr>
-        <p:spPr>
-          <a:xfrm>
-            <a:off x="8503920" y="2395728"/>
-            <a:ext cx="347472" cy="347472"/>
-          </a:xfrm>
-          <a:prstGeom prst="rect">
-            <a:avLst/>
-          </a:prstGeom>
-          <a:noFill/>
-          <a:ln/>
-        </p:spPr>
-        <p:txBody>
-          <a:bodyPr wrap="square" lIns="0" tIns="0" rIns="0" bIns="0" rtlCol="0" anchor="ctr"/>
-          <a:lstStyle/>
-          <a:p>
-            <a:pPr algn="ctr" indent="0" marL="0">
-              <a:buNone/>
-            </a:pPr>
-            <a:r>
-              <a:rPr lang="en-US" sz="1300" b="1" dirty="0">
-                <a:solidFill>
-                  <a:schemeClr val="bg1"/>
-                </a:solidFill>
-              </a:rPr>
-              <a:t>2</a:t>
-            </a:r>
-            <a:endParaRPr lang="en-US" sz="1300" dirty="0"/>
-          </a:p>
-        </p:txBody>
-      </p:sp>
-      <p:sp>
-        <p:nvSpPr>
-          <p:cNvPr id="10" name="Step 2 text"/>
-          <p:cNvSpPr txBox="1"/>
-          <p:nvPr/>
-        </p:nvSpPr>
-        <p:spPr>
-          <a:xfrm>
-            <a:off x="8979408" y="2377440"/>
-            <a:ext cx="2770632" cy="1115568"/>
-          </a:xfrm>
-          <a:prstGeom prst="rect">
-            <a:avLst/>
-          </a:prstGeom>
-          <a:noFill/>
-          <a:ln/>
-        </p:spPr>
-        <p:txBody>
-          <a:bodyPr wrap="square" lIns="0" tIns="0" rIns="0" bIns="0" rtlCol="0" anchor="t"/>
-          <a:lstStyle/>
-          <a:p>
-            <a:pPr indent="0" marL="0">
-              <a:buNone/>
-            </a:pPr>
-            <a:r>
-              <a:rPr lang="en-US" sz="1350" dirty="0">
-                <a:solidFill>
-                  <a:schemeClr val="tx1"/>
-                </a:solidFill>
-              </a:rPr>
-              <a:t>Access for colleagues and password help.</a:t>
-            </a:r>
-            <a:endParaRPr lang="en-US" sz="1350" dirty="0"/>
+              <a:t>Check cover, brush up on the portal, and talk directly to the underwriters who make the decisions.</a:t>
+            </a:r>
+            <a:endParaRPr lang="en-US" sz="2000" dirty="0"/>
           </a:p>
         </p:txBody>
       </p:sp>
@@ -6981,7 +7251,7 @@
         </p:nvSpPr>
         <p:spPr>
           <a:xfrm>
-            <a:off x="11201400" y="6446520"/>
+            <a:off x="11155680" y="6263640"/>
             <a:ext cx="548640" cy="274320"/>
           </a:xfrm>
           <a:prstGeom prst="rect">
@@ -6999,7 +7269,7 @@
             <a:lvl1pPr>
               <a:defRPr sz="1000">
                 <a:solidFill>
-                  <a:srgbClr val="6B6E72"/>
+                  <a:srgbClr val="FFFFFF"/>
                 </a:solidFill>
               </a:defRPr>
             </a:lvl1pPr>
@@ -7071,7 +7341,7 @@
                   <a:schemeClr val="tx2"/>
                 </a:solidFill>
               </a:rPr>
-              <a:t>We're here to help</a:t>
+              <a:t>Policy wordings</a:t>
             </a:r>
             <a:endParaRPr lang="en-US" sz="2800" dirty="0"/>
           </a:p>
@@ -7079,51 +7349,80 @@
       </p:sp>
       <p:sp>
         <p:nvSpPr>
-          <p:cNvPr id="3" name="Point 1"/>
+          <p:cNvPr id="3" name="Screenshot frame"/>
           <p:cNvSpPr/>
           <p:nvPr/>
         </p:nvSpPr>
         <p:spPr>
           <a:xfrm>
-            <a:off x="457200" y="1417320"/>
-            <a:ext cx="11247120" cy="960120"/>
-          </a:xfrm>
-          <a:prstGeom prst="roundRect">
-            <a:avLst>
-              <a:gd name="adj" fmla="val 7619"/>
-            </a:avLst>
+            <a:off x="402336" y="1133856"/>
+            <a:ext cx="7790688" cy="4910328"/>
+          </a:xfrm>
+          <a:prstGeom prst="rect">
+            <a:avLst/>
           </a:prstGeom>
           <a:solidFill>
             <a:schemeClr val="bg1"/>
           </a:solidFill>
           <a:ln w="12700">
             <a:solidFill>
-              <a:srgbClr val="DDE7E5"/>
+              <a:srgbClr val="D5DFDD"/>
             </a:solidFill>
             <a:prstDash val="solid"/>
           </a:ln>
-        </p:spPr>
-      </p:sp>
-      <p:sp>
-        <p:nvSpPr>
-          <p:cNvPr id="4" name="Point 1 marker"/>
+          <a:effectLst>
+            <a:outerShdw sx="100000" sy="100000" kx="0" ky="0" algn="bl" rotWithShape="0" blurRad="76200" dist="25400" dir="5400000">
+              <a:srgbClr val="000000">
+                <a:alpha val="12000"/>
+              </a:srgbClr>
+            </a:outerShdw>
+          </a:effectLst>
+        </p:spPr>
+      </p:sp>
+      <p:pic>
+        <p:nvPicPr>
+          <p:cNvPr id="4" name="Screenshot" descr="Policy wordings: screenshot with numbered callouts">    </p:cNvPr>
+          <p:cNvPicPr>
+            <a:picLocks noChangeAspect="1"/>
+          </p:cNvPicPr>
+          <p:nvPr/>
+        </p:nvPicPr>
+        <p:blipFill>
+          <a:blip r:embed="rId1"/>
+          <a:stretch>
+            <a:fillRect/>
+          </a:stretch>
+        </p:blipFill>
+        <p:spPr>
+          <a:xfrm>
+            <a:off x="457200" y="1188720"/>
+            <a:ext cx="7680960" cy="4800600"/>
+          </a:xfrm>
+          <a:prstGeom prst="rect">
+            <a:avLst/>
+          </a:prstGeom>
+        </p:spPr>
+      </p:pic>
+      <p:sp>
+        <p:nvSpPr>
+          <p:cNvPr id="5" name="Step 1 marker"/>
           <p:cNvSpPr/>
           <p:nvPr/>
         </p:nvSpPr>
         <p:spPr>
           <a:xfrm>
-            <a:off x="731520" y="1664208"/>
-            <a:ext cx="457200" cy="457200"/>
+            <a:off x="8503920" y="1207008"/>
+            <a:ext cx="347472" cy="347472"/>
           </a:xfrm>
           <a:prstGeom prst="ellipse">
             <a:avLst/>
           </a:prstGeom>
           <a:solidFill>
-            <a:schemeClr val="accent2"/>
+            <a:schemeClr val="accent3"/>
           </a:solidFill>
           <a:ln w="12700">
             <a:solidFill>
-              <a:schemeClr val="accent2"/>
+              <a:schemeClr val="accent3"/>
             </a:solidFill>
             <a:prstDash val="solid"/>
           </a:ln>
@@ -7131,14 +7430,14 @@
       </p:sp>
       <p:sp>
         <p:nvSpPr>
-          <p:cNvPr id="5" name="Point 1 tick"/>
+          <p:cNvPr id="6" name="Step 1 number"/>
           <p:cNvSpPr txBox="1"/>
           <p:nvPr/>
         </p:nvSpPr>
         <p:spPr>
           <a:xfrm>
-            <a:off x="731520" y="1664208"/>
-            <a:ext cx="457200" cy="457200"/>
+            <a:off x="8503920" y="1207008"/>
+            <a:ext cx="347472" cy="347472"/>
           </a:xfrm>
           <a:prstGeom prst="rect">
             <a:avLst/>
@@ -7154,75 +7453,73 @@
               <a:buNone/>
             </a:pPr>
             <a:r>
-              <a:rPr lang="en-US" sz="1600" b="1" dirty="0">
+              <a:rPr lang="en-US" sz="1300" b="1" dirty="0">
                 <a:solidFill>
                   <a:schemeClr val="bg1"/>
                 </a:solidFill>
               </a:rPr>
-              <a:t>✓</a:t>
-            </a:r>
-            <a:endParaRPr lang="en-US" sz="1600" dirty="0"/>
-          </a:p>
-        </p:txBody>
-      </p:sp>
-      <p:sp>
-        <p:nvSpPr>
-          <p:cNvPr id="6" name="Point 1 text"/>
+              <a:t>1</a:t>
+            </a:r>
+            <a:endParaRPr lang="en-US" sz="1300" dirty="0"/>
+          </a:p>
+        </p:txBody>
+      </p:sp>
+      <p:sp>
+        <p:nvSpPr>
+          <p:cNvPr id="7" name="Step 1 text"/>
           <p:cNvSpPr txBox="1"/>
           <p:nvPr/>
         </p:nvSpPr>
         <p:spPr>
           <a:xfrm>
-            <a:off x="1463040" y="1417320"/>
-            <a:ext cx="9966960" cy="960120"/>
-          </a:xfrm>
-          <a:prstGeom prst="rect">
-            <a:avLst/>
-          </a:prstGeom>
-          <a:noFill/>
-          <a:ln/>
-        </p:spPr>
-        <p:txBody>
-          <a:bodyPr wrap="square" lIns="0" tIns="0" rIns="0" bIns="0" rtlCol="0" anchor="ctr"/>
+            <a:off x="8979408" y="1188720"/>
+            <a:ext cx="2770632" cy="1115568"/>
+          </a:xfrm>
+          <a:prstGeom prst="rect">
+            <a:avLst/>
+          </a:prstGeom>
+          <a:noFill/>
+          <a:ln/>
+        </p:spPr>
+        <p:txBody>
+          <a:bodyPr wrap="square" lIns="0" tIns="0" rIns="0" bIns="0" rtlCol="0" anchor="t"/>
           <a:lstStyle/>
           <a:p>
             <a:pPr indent="0" marL="0">
               <a:buNone/>
             </a:pPr>
             <a:r>
-              <a:rPr lang="en-US" sz="1800" dirty="0">
+              <a:rPr lang="en-US" sz="1350" dirty="0">
                 <a:solidFill>
                   <a:schemeClr val="tx1"/>
                 </a:solidFill>
               </a:rPr>
-              <a:t>Call us on 0800 003 545.</a:t>
-            </a:r>
-            <a:endParaRPr lang="en-US" sz="1800" dirty="0"/>
-          </a:p>
-        </p:txBody>
-      </p:sp>
-      <p:sp>
-        <p:nvSpPr>
-          <p:cNvPr id="7" name="Point 2"/>
+              <a:t>Wordings grouped by product.</a:t>
+            </a:r>
+            <a:endParaRPr lang="en-US" sz="1350" dirty="0"/>
+          </a:p>
+        </p:txBody>
+      </p:sp>
+      <p:sp>
+        <p:nvSpPr>
+          <p:cNvPr id="8" name="Step 2 marker"/>
           <p:cNvSpPr/>
           <p:nvPr/>
         </p:nvSpPr>
         <p:spPr>
           <a:xfrm>
-            <a:off x="457200" y="2560320"/>
-            <a:ext cx="11247120" cy="960120"/>
-          </a:xfrm>
-          <a:prstGeom prst="roundRect">
-            <a:avLst>
-              <a:gd name="adj" fmla="val 7619"/>
-            </a:avLst>
+            <a:off x="8503920" y="2395728"/>
+            <a:ext cx="347472" cy="347472"/>
+          </a:xfrm>
+          <a:prstGeom prst="ellipse">
+            <a:avLst/>
           </a:prstGeom>
           <a:solidFill>
-            <a:schemeClr val="bg1"/>
+            <a:schemeClr val="accent3"/>
           </a:solidFill>
           <a:ln w="12700">
             <a:solidFill>
-              <a:srgbClr val="DDE7E5"/>
+              <a:schemeClr val="accent3"/>
             </a:solidFill>
             <a:prstDash val="solid"/>
           </a:ln>
@@ -7230,24 +7527,96 @@
       </p:sp>
       <p:sp>
         <p:nvSpPr>
-          <p:cNvPr id="8" name="Point 2 marker"/>
+          <p:cNvPr id="9" name="Step 2 number"/>
+          <p:cNvSpPr txBox="1"/>
+          <p:nvPr/>
+        </p:nvSpPr>
+        <p:spPr>
+          <a:xfrm>
+            <a:off x="8503920" y="2395728"/>
+            <a:ext cx="347472" cy="347472"/>
+          </a:xfrm>
+          <a:prstGeom prst="rect">
+            <a:avLst/>
+          </a:prstGeom>
+          <a:noFill/>
+          <a:ln/>
+        </p:spPr>
+        <p:txBody>
+          <a:bodyPr wrap="square" lIns="0" tIns="0" rIns="0" bIns="0" rtlCol="0" anchor="ctr"/>
+          <a:lstStyle/>
+          <a:p>
+            <a:pPr algn="ctr" indent="0" marL="0">
+              <a:buNone/>
+            </a:pPr>
+            <a:r>
+              <a:rPr lang="en-US" sz="1300" b="1" dirty="0">
+                <a:solidFill>
+                  <a:schemeClr val="bg1"/>
+                </a:solidFill>
+              </a:rPr>
+              <a:t>2</a:t>
+            </a:r>
+            <a:endParaRPr lang="en-US" sz="1300" dirty="0"/>
+          </a:p>
+        </p:txBody>
+      </p:sp>
+      <p:sp>
+        <p:nvSpPr>
+          <p:cNvPr id="10" name="Step 2 text"/>
+          <p:cNvSpPr txBox="1"/>
+          <p:nvPr/>
+        </p:nvSpPr>
+        <p:spPr>
+          <a:xfrm>
+            <a:off x="8979408" y="2377440"/>
+            <a:ext cx="2770632" cy="1115568"/>
+          </a:xfrm>
+          <a:prstGeom prst="rect">
+            <a:avLst/>
+          </a:prstGeom>
+          <a:noFill/>
+          <a:ln/>
+        </p:spPr>
+        <p:txBody>
+          <a:bodyPr wrap="square" lIns="0" tIns="0" rIns="0" bIns="0" rtlCol="0" anchor="t"/>
+          <a:lstStyle/>
+          <a:p>
+            <a:pPr indent="0" marL="0">
+              <a:buNone/>
+            </a:pPr>
+            <a:r>
+              <a:rPr lang="en-US" sz="1350" dirty="0">
+                <a:solidFill>
+                  <a:schemeClr val="tx1"/>
+                </a:solidFill>
+              </a:rPr>
+              <a:t>Where a wording covers more than one product, it says which.</a:t>
+            </a:r>
+            <a:endParaRPr lang="en-US" sz="1350" dirty="0"/>
+          </a:p>
+        </p:txBody>
+      </p:sp>
+      <p:sp>
+        <p:nvSpPr>
+          <p:cNvPr id="11" name="Step 3 marker"/>
           <p:cNvSpPr/>
           <p:nvPr/>
         </p:nvSpPr>
         <p:spPr>
           <a:xfrm>
-            <a:off x="731520" y="2807208"/>
-            <a:ext cx="457200" cy="457200"/>
+            <a:off x="8503920" y="3584448"/>
+            <a:ext cx="347472" cy="347472"/>
           </a:xfrm>
           <a:prstGeom prst="ellipse">
             <a:avLst/>
           </a:prstGeom>
           <a:solidFill>
-            <a:schemeClr val="accent2"/>
+            <a:schemeClr val="accent3"/>
           </a:solidFill>
           <a:ln w="12700">
             <a:solidFill>
-              <a:schemeClr val="accent2"/>
+              <a:schemeClr val="accent3"/>
             </a:solidFill>
             <a:prstDash val="solid"/>
           </a:ln>
@@ -7255,14 +7624,14 @@
       </p:sp>
       <p:sp>
         <p:nvSpPr>
-          <p:cNvPr id="9" name="Point 2 tick"/>
+          <p:cNvPr id="12" name="Step 3 number"/>
           <p:cNvSpPr txBox="1"/>
           <p:nvPr/>
         </p:nvSpPr>
         <p:spPr>
           <a:xfrm>
-            <a:off x="731520" y="2807208"/>
-            <a:ext cx="457200" cy="457200"/>
+            <a:off x="8503920" y="3584448"/>
+            <a:ext cx="347472" cy="347472"/>
           </a:xfrm>
           <a:prstGeom prst="rect">
             <a:avLst/>
@@ -7278,298 +7647,50 @@
               <a:buNone/>
             </a:pPr>
             <a:r>
-              <a:rPr lang="en-US" sz="1600" b="1" dirty="0">
+              <a:rPr lang="en-US" sz="1300" b="1" dirty="0">
                 <a:solidFill>
                   <a:schemeClr val="bg1"/>
                 </a:solidFill>
               </a:rPr>
-              <a:t>✓</a:t>
-            </a:r>
-            <a:endParaRPr lang="en-US" sz="1600" dirty="0"/>
-          </a:p>
-        </p:txBody>
-      </p:sp>
-      <p:sp>
-        <p:nvSpPr>
-          <p:cNvPr id="10" name="Point 2 text"/>
+              <a:t>3</a:t>
+            </a:r>
+            <a:endParaRPr lang="en-US" sz="1300" dirty="0"/>
+          </a:p>
+        </p:txBody>
+      </p:sp>
+      <p:sp>
+        <p:nvSpPr>
+          <p:cNvPr id="13" name="Step 3 text"/>
           <p:cNvSpPr txBox="1"/>
           <p:nvPr/>
         </p:nvSpPr>
         <p:spPr>
           <a:xfrm>
-            <a:off x="1463040" y="2560320"/>
-            <a:ext cx="9966960" cy="960120"/>
-          </a:xfrm>
-          <a:prstGeom prst="rect">
-            <a:avLst/>
-          </a:prstGeom>
-          <a:noFill/>
-          <a:ln/>
-        </p:spPr>
-        <p:txBody>
-          <a:bodyPr wrap="square" lIns="0" tIns="0" rIns="0" bIns="0" rtlCol="0" anchor="ctr"/>
+            <a:off x="8979408" y="3566160"/>
+            <a:ext cx="2770632" cy="1115568"/>
+          </a:xfrm>
+          <a:prstGeom prst="rect">
+            <a:avLst/>
+          </a:prstGeom>
+          <a:noFill/>
+          <a:ln/>
+        </p:spPr>
+        <p:txBody>
+          <a:bodyPr wrap="square" lIns="0" tIns="0" rIns="0" bIns="0" rtlCol="0" anchor="t"/>
           <a:lstStyle/>
           <a:p>
             <a:pPr indent="0" marL="0">
               <a:buNone/>
             </a:pPr>
             <a:r>
-              <a:rPr lang="en-US" sz="1800" dirty="0">
+              <a:rPr lang="en-US" sz="1350" dirty="0">
                 <a:solidFill>
                   <a:schemeClr val="tx1"/>
                 </a:solidFill>
               </a:rPr>
-              <a:t>Email hello@ottainsurance.co.nz, or the team listed under Help &amp; contact.</a:t>
-            </a:r>
-            <a:endParaRPr lang="en-US" sz="1800" dirty="0"/>
-          </a:p>
-        </p:txBody>
-      </p:sp>
-      <p:sp>
-        <p:nvSpPr>
-          <p:cNvPr id="11" name="Point 3"/>
-          <p:cNvSpPr/>
-          <p:nvPr/>
-        </p:nvSpPr>
-        <p:spPr>
-          <a:xfrm>
-            <a:off x="457200" y="3703320"/>
-            <a:ext cx="11247120" cy="960120"/>
-          </a:xfrm>
-          <a:prstGeom prst="roundRect">
-            <a:avLst>
-              <a:gd name="adj" fmla="val 7619"/>
-            </a:avLst>
-          </a:prstGeom>
-          <a:solidFill>
-            <a:schemeClr val="bg1"/>
-          </a:solidFill>
-          <a:ln w="12700">
-            <a:solidFill>
-              <a:srgbClr val="DDE7E5"/>
-            </a:solidFill>
-            <a:prstDash val="solid"/>
-          </a:ln>
-        </p:spPr>
-      </p:sp>
-      <p:sp>
-        <p:nvSpPr>
-          <p:cNvPr id="12" name="Point 3 marker"/>
-          <p:cNvSpPr/>
-          <p:nvPr/>
-        </p:nvSpPr>
-        <p:spPr>
-          <a:xfrm>
-            <a:off x="731520" y="3950208"/>
-            <a:ext cx="457200" cy="457200"/>
-          </a:xfrm>
-          <a:prstGeom prst="ellipse">
-            <a:avLst/>
-          </a:prstGeom>
-          <a:solidFill>
-            <a:schemeClr val="accent2"/>
-          </a:solidFill>
-          <a:ln w="12700">
-            <a:solidFill>
-              <a:schemeClr val="accent2"/>
-            </a:solidFill>
-            <a:prstDash val="solid"/>
-          </a:ln>
-        </p:spPr>
-      </p:sp>
-      <p:sp>
-        <p:nvSpPr>
-          <p:cNvPr id="13" name="Point 3 tick"/>
-          <p:cNvSpPr txBox="1"/>
-          <p:nvPr/>
-        </p:nvSpPr>
-        <p:spPr>
-          <a:xfrm>
-            <a:off x="731520" y="3950208"/>
-            <a:ext cx="457200" cy="457200"/>
-          </a:xfrm>
-          <a:prstGeom prst="rect">
-            <a:avLst/>
-          </a:prstGeom>
-          <a:noFill/>
-          <a:ln/>
-        </p:spPr>
-        <p:txBody>
-          <a:bodyPr wrap="square" lIns="0" tIns="0" rIns="0" bIns="0" rtlCol="0" anchor="ctr"/>
-          <a:lstStyle/>
-          <a:p>
-            <a:pPr algn="ctr" indent="0" marL="0">
-              <a:buNone/>
-            </a:pPr>
-            <a:r>
-              <a:rPr lang="en-US" sz="1600" b="1" dirty="0">
-                <a:solidFill>
-                  <a:schemeClr val="bg1"/>
-                </a:solidFill>
-              </a:rPr>
-              <a:t>✓</a:t>
-            </a:r>
-            <a:endParaRPr lang="en-US" sz="1600" dirty="0"/>
-          </a:p>
-        </p:txBody>
-      </p:sp>
-      <p:sp>
-        <p:nvSpPr>
-          <p:cNvPr id="14" name="Point 3 text"/>
-          <p:cNvSpPr txBox="1"/>
-          <p:nvPr/>
-        </p:nvSpPr>
-        <p:spPr>
-          <a:xfrm>
-            <a:off x="1463040" y="3703320"/>
-            <a:ext cx="9966960" cy="960120"/>
-          </a:xfrm>
-          <a:prstGeom prst="rect">
-            <a:avLst/>
-          </a:prstGeom>
-          <a:noFill/>
-          <a:ln/>
-        </p:spPr>
-        <p:txBody>
-          <a:bodyPr wrap="square" lIns="0" tIns="0" rIns="0" bIns="0" rtlCol="0" anchor="ctr"/>
-          <a:lstStyle/>
-          <a:p>
-            <a:pPr indent="0" marL="0">
-              <a:buNone/>
-            </a:pPr>
-            <a:r>
-              <a:rPr lang="en-US" sz="1800" dirty="0">
-                <a:solidFill>
-                  <a:schemeClr val="tx1"/>
-                </a:solidFill>
-              </a:rPr>
-              <a:t>Claims: claims@ottainsurance.co.nz.</a:t>
-            </a:r>
-            <a:endParaRPr lang="en-US" sz="1800" dirty="0"/>
-          </a:p>
-        </p:txBody>
-      </p:sp>
-      <p:sp>
-        <p:nvSpPr>
-          <p:cNvPr id="15" name="Point 4"/>
-          <p:cNvSpPr/>
-          <p:nvPr/>
-        </p:nvSpPr>
-        <p:spPr>
-          <a:xfrm>
-            <a:off x="457200" y="4846320"/>
-            <a:ext cx="11247120" cy="960120"/>
-          </a:xfrm>
-          <a:prstGeom prst="roundRect">
-            <a:avLst>
-              <a:gd name="adj" fmla="val 7619"/>
-            </a:avLst>
-          </a:prstGeom>
-          <a:solidFill>
-            <a:schemeClr val="bg1"/>
-          </a:solidFill>
-          <a:ln w="12700">
-            <a:solidFill>
-              <a:srgbClr val="DDE7E5"/>
-            </a:solidFill>
-            <a:prstDash val="solid"/>
-          </a:ln>
-        </p:spPr>
-      </p:sp>
-      <p:sp>
-        <p:nvSpPr>
-          <p:cNvPr id="16" name="Point 4 marker"/>
-          <p:cNvSpPr/>
-          <p:nvPr/>
-        </p:nvSpPr>
-        <p:spPr>
-          <a:xfrm>
-            <a:off x="731520" y="5093208"/>
-            <a:ext cx="457200" cy="457200"/>
-          </a:xfrm>
-          <a:prstGeom prst="ellipse">
-            <a:avLst/>
-          </a:prstGeom>
-          <a:solidFill>
-            <a:schemeClr val="accent2"/>
-          </a:solidFill>
-          <a:ln w="12700">
-            <a:solidFill>
-              <a:schemeClr val="accent2"/>
-            </a:solidFill>
-            <a:prstDash val="solid"/>
-          </a:ln>
-        </p:spPr>
-      </p:sp>
-      <p:sp>
-        <p:nvSpPr>
-          <p:cNvPr id="17" name="Point 4 tick"/>
-          <p:cNvSpPr txBox="1"/>
-          <p:nvPr/>
-        </p:nvSpPr>
-        <p:spPr>
-          <a:xfrm>
-            <a:off x="731520" y="5093208"/>
-            <a:ext cx="457200" cy="457200"/>
-          </a:xfrm>
-          <a:prstGeom prst="rect">
-            <a:avLst/>
-          </a:prstGeom>
-          <a:noFill/>
-          <a:ln/>
-        </p:spPr>
-        <p:txBody>
-          <a:bodyPr wrap="square" lIns="0" tIns="0" rIns="0" bIns="0" rtlCol="0" anchor="ctr"/>
-          <a:lstStyle/>
-          <a:p>
-            <a:pPr algn="ctr" indent="0" marL="0">
-              <a:buNone/>
-            </a:pPr>
-            <a:r>
-              <a:rPr lang="en-US" sz="1600" b="1" dirty="0">
-                <a:solidFill>
-                  <a:schemeClr val="bg1"/>
-                </a:solidFill>
-              </a:rPr>
-              <a:t>✓</a:t>
-            </a:r>
-            <a:endParaRPr lang="en-US" sz="1600" dirty="0"/>
-          </a:p>
-        </p:txBody>
-      </p:sp>
-      <p:sp>
-        <p:nvSpPr>
-          <p:cNvPr id="18" name="Point 4 text"/>
-          <p:cNvSpPr txBox="1"/>
-          <p:nvPr/>
-        </p:nvSpPr>
-        <p:spPr>
-          <a:xfrm>
-            <a:off x="1463040" y="4846320"/>
-            <a:ext cx="9966960" cy="960120"/>
-          </a:xfrm>
-          <a:prstGeom prst="rect">
-            <a:avLst/>
-          </a:prstGeom>
-          <a:noFill/>
-          <a:ln/>
-        </p:spPr>
-        <p:txBody>
-          <a:bodyPr wrap="square" lIns="0" tIns="0" rIns="0" bIns="0" rtlCol="0" anchor="ctr"/>
-          <a:lstStyle/>
-          <a:p>
-            <a:pPr indent="0" marL="0">
-              <a:buNone/>
-            </a:pPr>
-            <a:r>
-              <a:rPr lang="en-US" sz="1800" dirty="0">
-                <a:solidFill>
-                  <a:schemeClr val="tx1"/>
-                </a:solidFill>
-              </a:rPr>
-              <a:t>Thanks for choosing Otta. We look forward to working with you.</a:t>
-            </a:r>
-            <a:endParaRPr lang="en-US" sz="1800" dirty="0"/>
+              <a:t>View or download the wording.</a:t>
+            </a:r>
+            <a:endParaRPr lang="en-US" sz="1350" dirty="0"/>
           </a:p>
         </p:txBody>
       </p:sp>
@@ -8119,7 +8240,7 @@
                   <a:schemeClr val="tx2"/>
                 </a:solidFill>
               </a:rPr>
-              <a:t>Complete or send a form</a:t>
+              <a:t>Complete or share a form</a:t>
             </a:r>
             <a:endParaRPr lang="en-US" sz="1900" dirty="0"/>
           </a:p>
@@ -8155,7 +8276,7 @@
                   <a:schemeClr val="tx1"/>
                 </a:solidFill>
               </a:rPr>
-              <a:t>Fill it in online, or send your client a secure link.</a:t>
+              <a:t>Fill it in online, or send your client a secure link yourself.</a:t>
             </a:r>
             <a:endParaRPr lang="en-US" sz="1500" dirty="0"/>
           </a:p>
@@ -8315,7 +8436,7 @@
                   <a:schemeClr val="tx1"/>
                 </a:solidFill>
               </a:rPr>
-              <a:t>See every application and quote, and bind accepted quotes.</a:t>
+              <a:t>Follow applications, quotes and claims, and bind accepted quotes.</a:t>
             </a:r>
             <a:endParaRPr lang="en-US" sz="1500" dirty="0"/>
           </a:p>
@@ -8521,6 +8642,1423 @@
             <a:fld id="{F7021451-1387-4CA6-816F-3879F97B5CBC}" type="slidenum">
               <a:rPr b="0" lang="en-US"/>
               <a:t>2</a:t>
+            </a:fld>
+            <a:endParaRPr lang="en-US"/>
+          </a:p>
+        </p:txBody>
+      </p:sp>
+    </p:spTree>
+  </p:cSld>
+  <p:clrMapOvr>
+    <a:masterClrMapping/>
+  </p:clrMapOvr>
+</p:sld>
+</file>
+
+<file path=ppt/slides/slide20.xml><?xml version="1.0" encoding="utf-8"?>
+<p:sld xmlns:a="http://schemas.openxmlformats.org/drawingml/2006/main" xmlns:r="http://schemas.openxmlformats.org/officeDocument/2006/relationships" xmlns:p="http://schemas.openxmlformats.org/presentationml/2006/main">
+  <p:cSld name="Slide 20">
+    <p:spTree>
+      <p:nvGrpSpPr>
+        <p:cNvPr id="1" name=""/>
+        <p:cNvGrpSpPr/>
+        <p:nvPr/>
+      </p:nvGrpSpPr>
+      <p:grpSpPr>
+        <a:xfrm>
+          <a:off x="0" y="0"/>
+          <a:ext cx="0" cy="0"/>
+          <a:chOff x="0" y="0"/>
+          <a:chExt cx="0" cy="0"/>
+        </a:xfrm>
+      </p:grpSpPr>
+      <p:sp>
+        <p:nvSpPr>
+          <p:cNvPr id="2" name="Text 0"/>
+          <p:cNvSpPr/>
+          <p:nvPr>
+            <p:ph idx="101" type="title" hasCustomPrompt="1"/>
+          </p:nvPr>
+        </p:nvSpPr>
+        <p:spPr>
+          <a:xfrm>
+            <a:off x="457200" y="274320"/>
+            <a:ext cx="10058400" cy="685800"/>
+          </a:xfrm>
+          <a:prstGeom prst="rect">
+            <a:avLst/>
+          </a:prstGeom>
+          <a:noFill/>
+          <a:ln/>
+        </p:spPr>
+        <p:txBody>
+          <a:bodyPr wrap="square" lIns="0" tIns="0" rIns="0" bIns="0" rtlCol="0" anchor="ctr"/>
+          <a:lstStyle/>
+          <a:p>
+            <a:pPr algn="l" indent="0" marL="0">
+              <a:buNone/>
+            </a:pPr>
+            <a:r>
+              <a:rPr lang="en-US" sz="2800" b="1" dirty="0">
+                <a:solidFill>
+                  <a:schemeClr val="tx2"/>
+                </a:solidFill>
+              </a:rPr>
+              <a:t>Training</a:t>
+            </a:r>
+            <a:endParaRPr lang="en-US" sz="2800" dirty="0"/>
+          </a:p>
+        </p:txBody>
+      </p:sp>
+      <p:sp>
+        <p:nvSpPr>
+          <p:cNvPr id="3" name="Screenshot frame"/>
+          <p:cNvSpPr/>
+          <p:nvPr/>
+        </p:nvSpPr>
+        <p:spPr>
+          <a:xfrm>
+            <a:off x="402336" y="1133856"/>
+            <a:ext cx="7790688" cy="4910328"/>
+          </a:xfrm>
+          <a:prstGeom prst="rect">
+            <a:avLst/>
+          </a:prstGeom>
+          <a:solidFill>
+            <a:schemeClr val="bg1"/>
+          </a:solidFill>
+          <a:ln w="12700">
+            <a:solidFill>
+              <a:srgbClr val="D5DFDD"/>
+            </a:solidFill>
+            <a:prstDash val="solid"/>
+          </a:ln>
+          <a:effectLst>
+            <a:outerShdw sx="100000" sy="100000" kx="0" ky="0" algn="bl" rotWithShape="0" blurRad="76200" dist="25400" dir="5400000">
+              <a:srgbClr val="000000">
+                <a:alpha val="12000"/>
+              </a:srgbClr>
+            </a:outerShdw>
+          </a:effectLst>
+        </p:spPr>
+      </p:sp>
+      <p:pic>
+        <p:nvPicPr>
+          <p:cNvPr id="4" name="Screenshot" descr="Training: screenshot with numbered callouts">    </p:cNvPr>
+          <p:cNvPicPr>
+            <a:picLocks noChangeAspect="1"/>
+          </p:cNvPicPr>
+          <p:nvPr/>
+        </p:nvPicPr>
+        <p:blipFill>
+          <a:blip r:embed="rId1"/>
+          <a:stretch>
+            <a:fillRect/>
+          </a:stretch>
+        </p:blipFill>
+        <p:spPr>
+          <a:xfrm>
+            <a:off x="457200" y="1188720"/>
+            <a:ext cx="7680960" cy="4800600"/>
+          </a:xfrm>
+          <a:prstGeom prst="rect">
+            <a:avLst/>
+          </a:prstGeom>
+        </p:spPr>
+      </p:pic>
+      <p:sp>
+        <p:nvSpPr>
+          <p:cNvPr id="5" name="Step 1 marker"/>
+          <p:cNvSpPr/>
+          <p:nvPr/>
+        </p:nvSpPr>
+        <p:spPr>
+          <a:xfrm>
+            <a:off x="8503920" y="1207008"/>
+            <a:ext cx="347472" cy="347472"/>
+          </a:xfrm>
+          <a:prstGeom prst="ellipse">
+            <a:avLst/>
+          </a:prstGeom>
+          <a:solidFill>
+            <a:schemeClr val="accent3"/>
+          </a:solidFill>
+          <a:ln w="12700">
+            <a:solidFill>
+              <a:schemeClr val="accent3"/>
+            </a:solidFill>
+            <a:prstDash val="solid"/>
+          </a:ln>
+        </p:spPr>
+      </p:sp>
+      <p:sp>
+        <p:nvSpPr>
+          <p:cNvPr id="6" name="Step 1 number"/>
+          <p:cNvSpPr txBox="1"/>
+          <p:nvPr/>
+        </p:nvSpPr>
+        <p:spPr>
+          <a:xfrm>
+            <a:off x="8503920" y="1207008"/>
+            <a:ext cx="347472" cy="347472"/>
+          </a:xfrm>
+          <a:prstGeom prst="rect">
+            <a:avLst/>
+          </a:prstGeom>
+          <a:noFill/>
+          <a:ln/>
+        </p:spPr>
+        <p:txBody>
+          <a:bodyPr wrap="square" lIns="0" tIns="0" rIns="0" bIns="0" rtlCol="0" anchor="ctr"/>
+          <a:lstStyle/>
+          <a:p>
+            <a:pPr algn="ctr" indent="0" marL="0">
+              <a:buNone/>
+            </a:pPr>
+            <a:r>
+              <a:rPr lang="en-US" sz="1300" b="1" dirty="0">
+                <a:solidFill>
+                  <a:schemeClr val="bg1"/>
+                </a:solidFill>
+              </a:rPr>
+              <a:t>1</a:t>
+            </a:r>
+            <a:endParaRPr lang="en-US" sz="1300" dirty="0"/>
+          </a:p>
+        </p:txBody>
+      </p:sp>
+      <p:sp>
+        <p:nvSpPr>
+          <p:cNvPr id="7" name="Step 1 text"/>
+          <p:cNvSpPr txBox="1"/>
+          <p:nvPr/>
+        </p:nvSpPr>
+        <p:spPr>
+          <a:xfrm>
+            <a:off x="8979408" y="1188720"/>
+            <a:ext cx="2770632" cy="1115568"/>
+          </a:xfrm>
+          <a:prstGeom prst="rect">
+            <a:avLst/>
+          </a:prstGeom>
+          <a:noFill/>
+          <a:ln/>
+        </p:spPr>
+        <p:txBody>
+          <a:bodyPr wrap="square" lIns="0" tIns="0" rIns="0" bIns="0" rtlCol="0" anchor="t"/>
+          <a:lstStyle/>
+          <a:p>
+            <a:pPr indent="0" marL="0">
+              <a:buNone/>
+            </a:pPr>
+            <a:r>
+              <a:rPr lang="en-US" sz="1350" dirty="0">
+                <a:solidFill>
+                  <a:schemeClr val="tx1"/>
+                </a:solidFill>
+              </a:rPr>
+              <a:t>Download this guide as a PDF.</a:t>
+            </a:r>
+            <a:endParaRPr lang="en-US" sz="1350" dirty="0"/>
+          </a:p>
+        </p:txBody>
+      </p:sp>
+      <p:sp>
+        <p:nvSpPr>
+          <p:cNvPr id="8" name="Step 2 marker"/>
+          <p:cNvSpPr/>
+          <p:nvPr/>
+        </p:nvSpPr>
+        <p:spPr>
+          <a:xfrm>
+            <a:off x="8503920" y="2395728"/>
+            <a:ext cx="347472" cy="347472"/>
+          </a:xfrm>
+          <a:prstGeom prst="ellipse">
+            <a:avLst/>
+          </a:prstGeom>
+          <a:solidFill>
+            <a:schemeClr val="accent3"/>
+          </a:solidFill>
+          <a:ln w="12700">
+            <a:solidFill>
+              <a:schemeClr val="accent3"/>
+            </a:solidFill>
+            <a:prstDash val="solid"/>
+          </a:ln>
+        </p:spPr>
+      </p:sp>
+      <p:sp>
+        <p:nvSpPr>
+          <p:cNvPr id="9" name="Step 2 number"/>
+          <p:cNvSpPr txBox="1"/>
+          <p:nvPr/>
+        </p:nvSpPr>
+        <p:spPr>
+          <a:xfrm>
+            <a:off x="8503920" y="2395728"/>
+            <a:ext cx="347472" cy="347472"/>
+          </a:xfrm>
+          <a:prstGeom prst="rect">
+            <a:avLst/>
+          </a:prstGeom>
+          <a:noFill/>
+          <a:ln/>
+        </p:spPr>
+        <p:txBody>
+          <a:bodyPr wrap="square" lIns="0" tIns="0" rIns="0" bIns="0" rtlCol="0" anchor="ctr"/>
+          <a:lstStyle/>
+          <a:p>
+            <a:pPr algn="ctr" indent="0" marL="0">
+              <a:buNone/>
+            </a:pPr>
+            <a:r>
+              <a:rPr lang="en-US" sz="1300" b="1" dirty="0">
+                <a:solidFill>
+                  <a:schemeClr val="bg1"/>
+                </a:solidFill>
+              </a:rPr>
+              <a:t>2</a:t>
+            </a:r>
+            <a:endParaRPr lang="en-US" sz="1300" dirty="0"/>
+          </a:p>
+        </p:txBody>
+      </p:sp>
+      <p:sp>
+        <p:nvSpPr>
+          <p:cNvPr id="10" name="Step 2 text"/>
+          <p:cNvSpPr txBox="1"/>
+          <p:nvPr/>
+        </p:nvSpPr>
+        <p:spPr>
+          <a:xfrm>
+            <a:off x="8979408" y="2377440"/>
+            <a:ext cx="2770632" cy="1115568"/>
+          </a:xfrm>
+          <a:prstGeom prst="rect">
+            <a:avLst/>
+          </a:prstGeom>
+          <a:noFill/>
+          <a:ln/>
+        </p:spPr>
+        <p:txBody>
+          <a:bodyPr wrap="square" lIns="0" tIns="0" rIns="0" bIns="0" rtlCol="0" anchor="t"/>
+          <a:lstStyle/>
+          <a:p>
+            <a:pPr indent="0" marL="0">
+              <a:buNone/>
+            </a:pPr>
+            <a:r>
+              <a:rPr lang="en-US" sz="1350" dirty="0">
+                <a:solidFill>
+                  <a:schemeClr val="tx1"/>
+                </a:solidFill>
+              </a:rPr>
+              <a:t>Getting started in five steps.</a:t>
+            </a:r>
+            <a:endParaRPr lang="en-US" sz="1350" dirty="0"/>
+          </a:p>
+        </p:txBody>
+      </p:sp>
+      <p:sp>
+        <p:nvSpPr>
+          <p:cNvPr id="11" name="Step 3 marker"/>
+          <p:cNvSpPr/>
+          <p:nvPr/>
+        </p:nvSpPr>
+        <p:spPr>
+          <a:xfrm>
+            <a:off x="8503920" y="3584448"/>
+            <a:ext cx="347472" cy="347472"/>
+          </a:xfrm>
+          <a:prstGeom prst="ellipse">
+            <a:avLst/>
+          </a:prstGeom>
+          <a:solidFill>
+            <a:schemeClr val="accent3"/>
+          </a:solidFill>
+          <a:ln w="12700">
+            <a:solidFill>
+              <a:schemeClr val="accent3"/>
+            </a:solidFill>
+            <a:prstDash val="solid"/>
+          </a:ln>
+        </p:spPr>
+      </p:sp>
+      <p:sp>
+        <p:nvSpPr>
+          <p:cNvPr id="12" name="Step 3 number"/>
+          <p:cNvSpPr txBox="1"/>
+          <p:nvPr/>
+        </p:nvSpPr>
+        <p:spPr>
+          <a:xfrm>
+            <a:off x="8503920" y="3584448"/>
+            <a:ext cx="347472" cy="347472"/>
+          </a:xfrm>
+          <a:prstGeom prst="rect">
+            <a:avLst/>
+          </a:prstGeom>
+          <a:noFill/>
+          <a:ln/>
+        </p:spPr>
+        <p:txBody>
+          <a:bodyPr wrap="square" lIns="0" tIns="0" rIns="0" bIns="0" rtlCol="0" anchor="ctr"/>
+          <a:lstStyle/>
+          <a:p>
+            <a:pPr algn="ctr" indent="0" marL="0">
+              <a:buNone/>
+            </a:pPr>
+            <a:r>
+              <a:rPr lang="en-US" sz="1300" b="1" dirty="0">
+                <a:solidFill>
+                  <a:schemeClr val="bg1"/>
+                </a:solidFill>
+              </a:rPr>
+              <a:t>3</a:t>
+            </a:r>
+            <a:endParaRPr lang="en-US" sz="1300" dirty="0"/>
+          </a:p>
+        </p:txBody>
+      </p:sp>
+      <p:sp>
+        <p:nvSpPr>
+          <p:cNvPr id="13" name="Step 3 text"/>
+          <p:cNvSpPr txBox="1"/>
+          <p:nvPr/>
+        </p:nvSpPr>
+        <p:spPr>
+          <a:xfrm>
+            <a:off x="8979408" y="3566160"/>
+            <a:ext cx="2770632" cy="1115568"/>
+          </a:xfrm>
+          <a:prstGeom prst="rect">
+            <a:avLst/>
+          </a:prstGeom>
+          <a:noFill/>
+          <a:ln/>
+        </p:spPr>
+        <p:txBody>
+          <a:bodyPr wrap="square" lIns="0" tIns="0" rIns="0" bIns="0" rtlCol="0" anchor="t"/>
+          <a:lstStyle/>
+          <a:p>
+            <a:pPr indent="0" marL="0">
+              <a:buNone/>
+            </a:pPr>
+            <a:r>
+              <a:rPr lang="en-US" sz="1350" dirty="0">
+                <a:solidFill>
+                  <a:schemeClr val="tx1"/>
+                </a:solidFill>
+              </a:rPr>
+              <a:t>A walkthrough of the portal, with screenshots.</a:t>
+            </a:r>
+            <a:endParaRPr lang="en-US" sz="1350" dirty="0"/>
+          </a:p>
+        </p:txBody>
+      </p:sp>
+      <p:sp>
+        <p:nvSpPr>
+          <p:cNvPr id="25" name="Slide Number Placeholder 0"/>
+          <p:cNvSpPr>
+            <a:spLocks noGrp="1"/>
+          </p:cNvSpPr>
+          <p:nvPr>
+            <p:ph type="sldNum" sz="quarter" idx="4294967295"/>
+          </p:nvPr>
+        </p:nvSpPr>
+        <p:spPr>
+          <a:xfrm>
+            <a:off x="11201400" y="6446520"/>
+            <a:ext cx="548640" cy="274320"/>
+          </a:xfrm>
+          <a:prstGeom prst="rect">
+            <a:avLst/>
+          </a:prstGeom>
+          <a:extLst>
+            <a:ext uri="{C572A759-6A51-4108-AA02-DFA0A04FC94B}">
+              <ma14:wrappingTextBoxFlag xmlns:ma14="http://schemas.microsoft.com/office/mac/drawingml/2011/main" val="0"/>
+            </a:ext>
+          </a:extLst>
+        </p:spPr>
+        <p:txBody>
+          <a:bodyPr/>
+          <a:lstStyle>
+            <a:lvl1pPr>
+              <a:defRPr sz="1000">
+                <a:solidFill>
+                  <a:srgbClr val="6B6E72"/>
+                </a:solidFill>
+              </a:defRPr>
+            </a:lvl1pPr>
+          </a:lstStyle>
+          <a:p>
+            <a:pPr algn="r"/>
+            <a:fld id="{F7021451-1387-4CA6-816F-3879F97B5CBC}" type="slidenum">
+              <a:rPr b="0" lang="en-US"/>
+              <a:t>20</a:t>
+            </a:fld>
+            <a:endParaRPr lang="en-US"/>
+          </a:p>
+        </p:txBody>
+      </p:sp>
+    </p:spTree>
+  </p:cSld>
+  <p:clrMapOvr>
+    <a:masterClrMapping/>
+  </p:clrMapOvr>
+</p:sld>
+</file>
+
+<file path=ppt/slides/slide21.xml><?xml version="1.0" encoding="utf-8"?>
+<p:sld xmlns:a="http://schemas.openxmlformats.org/drawingml/2006/main" xmlns:r="http://schemas.openxmlformats.org/officeDocument/2006/relationships" xmlns:p="http://schemas.openxmlformats.org/presentationml/2006/main">
+  <p:cSld name="Slide 21">
+    <p:spTree>
+      <p:nvGrpSpPr>
+        <p:cNvPr id="1" name=""/>
+        <p:cNvGrpSpPr/>
+        <p:nvPr/>
+      </p:nvGrpSpPr>
+      <p:grpSpPr>
+        <a:xfrm>
+          <a:off x="0" y="0"/>
+          <a:ext cx="0" cy="0"/>
+          <a:chOff x="0" y="0"/>
+          <a:chExt cx="0" cy="0"/>
+        </a:xfrm>
+      </p:grpSpPr>
+      <p:sp>
+        <p:nvSpPr>
+          <p:cNvPr id="2" name="Text 0"/>
+          <p:cNvSpPr/>
+          <p:nvPr>
+            <p:ph idx="101" type="title" hasCustomPrompt="1"/>
+          </p:nvPr>
+        </p:nvSpPr>
+        <p:spPr>
+          <a:xfrm>
+            <a:off x="457200" y="274320"/>
+            <a:ext cx="10058400" cy="685800"/>
+          </a:xfrm>
+          <a:prstGeom prst="rect">
+            <a:avLst/>
+          </a:prstGeom>
+          <a:noFill/>
+          <a:ln/>
+        </p:spPr>
+        <p:txBody>
+          <a:bodyPr wrap="square" lIns="0" tIns="0" rIns="0" bIns="0" rtlCol="0" anchor="ctr"/>
+          <a:lstStyle/>
+          <a:p>
+            <a:pPr algn="l" indent="0" marL="0">
+              <a:buNone/>
+            </a:pPr>
+            <a:r>
+              <a:rPr lang="en-US" sz="2800" b="1" dirty="0">
+                <a:solidFill>
+                  <a:schemeClr val="tx2"/>
+                </a:solidFill>
+              </a:rPr>
+              <a:t>Help and contact</a:t>
+            </a:r>
+            <a:endParaRPr lang="en-US" sz="2800" dirty="0"/>
+          </a:p>
+        </p:txBody>
+      </p:sp>
+      <p:sp>
+        <p:nvSpPr>
+          <p:cNvPr id="3" name="Screenshot frame"/>
+          <p:cNvSpPr/>
+          <p:nvPr/>
+        </p:nvSpPr>
+        <p:spPr>
+          <a:xfrm>
+            <a:off x="402336" y="1133856"/>
+            <a:ext cx="7790688" cy="4910328"/>
+          </a:xfrm>
+          <a:prstGeom prst="rect">
+            <a:avLst/>
+          </a:prstGeom>
+          <a:solidFill>
+            <a:schemeClr val="bg1"/>
+          </a:solidFill>
+          <a:ln w="12700">
+            <a:solidFill>
+              <a:srgbClr val="D5DFDD"/>
+            </a:solidFill>
+            <a:prstDash val="solid"/>
+          </a:ln>
+          <a:effectLst>
+            <a:outerShdw sx="100000" sy="100000" kx="0" ky="0" algn="bl" rotWithShape="0" blurRad="76200" dist="25400" dir="5400000">
+              <a:srgbClr val="000000">
+                <a:alpha val="12000"/>
+              </a:srgbClr>
+            </a:outerShdw>
+          </a:effectLst>
+        </p:spPr>
+      </p:sp>
+      <p:pic>
+        <p:nvPicPr>
+          <p:cNvPr id="4" name="Screenshot" descr="Help and contact: screenshot with numbered callouts">    </p:cNvPr>
+          <p:cNvPicPr>
+            <a:picLocks noChangeAspect="1"/>
+          </p:cNvPicPr>
+          <p:nvPr/>
+        </p:nvPicPr>
+        <p:blipFill>
+          <a:blip r:embed="rId1"/>
+          <a:stretch>
+            <a:fillRect/>
+          </a:stretch>
+        </p:blipFill>
+        <p:spPr>
+          <a:xfrm>
+            <a:off x="457200" y="1188720"/>
+            <a:ext cx="7680960" cy="4800600"/>
+          </a:xfrm>
+          <a:prstGeom prst="rect">
+            <a:avLst/>
+          </a:prstGeom>
+        </p:spPr>
+      </p:pic>
+      <p:sp>
+        <p:nvSpPr>
+          <p:cNvPr id="5" name="Step 1 marker"/>
+          <p:cNvSpPr/>
+          <p:nvPr/>
+        </p:nvSpPr>
+        <p:spPr>
+          <a:xfrm>
+            <a:off x="8503920" y="1207008"/>
+            <a:ext cx="347472" cy="347472"/>
+          </a:xfrm>
+          <a:prstGeom prst="ellipse">
+            <a:avLst/>
+          </a:prstGeom>
+          <a:solidFill>
+            <a:schemeClr val="accent3"/>
+          </a:solidFill>
+          <a:ln w="12700">
+            <a:solidFill>
+              <a:schemeClr val="accent3"/>
+            </a:solidFill>
+            <a:prstDash val="solid"/>
+          </a:ln>
+        </p:spPr>
+      </p:sp>
+      <p:sp>
+        <p:nvSpPr>
+          <p:cNvPr id="6" name="Step 1 number"/>
+          <p:cNvSpPr txBox="1"/>
+          <p:nvPr/>
+        </p:nvSpPr>
+        <p:spPr>
+          <a:xfrm>
+            <a:off x="8503920" y="1207008"/>
+            <a:ext cx="347472" cy="347472"/>
+          </a:xfrm>
+          <a:prstGeom prst="rect">
+            <a:avLst/>
+          </a:prstGeom>
+          <a:noFill/>
+          <a:ln/>
+        </p:spPr>
+        <p:txBody>
+          <a:bodyPr wrap="square" lIns="0" tIns="0" rIns="0" bIns="0" rtlCol="0" anchor="ctr"/>
+          <a:lstStyle/>
+          <a:p>
+            <a:pPr algn="ctr" indent="0" marL="0">
+              <a:buNone/>
+            </a:pPr>
+            <a:r>
+              <a:rPr lang="en-US" sz="1300" b="1" dirty="0">
+                <a:solidFill>
+                  <a:schemeClr val="bg1"/>
+                </a:solidFill>
+              </a:rPr>
+              <a:t>1</a:t>
+            </a:r>
+            <a:endParaRPr lang="en-US" sz="1300" dirty="0"/>
+          </a:p>
+        </p:txBody>
+      </p:sp>
+      <p:sp>
+        <p:nvSpPr>
+          <p:cNvPr id="7" name="Step 1 text"/>
+          <p:cNvSpPr txBox="1"/>
+          <p:nvPr/>
+        </p:nvSpPr>
+        <p:spPr>
+          <a:xfrm>
+            <a:off x="8979408" y="1188720"/>
+            <a:ext cx="2770632" cy="1115568"/>
+          </a:xfrm>
+          <a:prstGeom prst="rect">
+            <a:avLst/>
+          </a:prstGeom>
+          <a:noFill/>
+          <a:ln/>
+        </p:spPr>
+        <p:txBody>
+          <a:bodyPr wrap="square" lIns="0" tIns="0" rIns="0" bIns="0" rtlCol="0" anchor="t"/>
+          <a:lstStyle/>
+          <a:p>
+            <a:pPr indent="0" marL="0">
+              <a:buNone/>
+            </a:pPr>
+            <a:r>
+              <a:rPr lang="en-US" sz="1350" dirty="0">
+                <a:solidFill>
+                  <a:schemeClr val="tx1"/>
+                </a:solidFill>
+              </a:rPr>
+              <a:t>Email the right team directly.</a:t>
+            </a:r>
+            <a:endParaRPr lang="en-US" sz="1350" dirty="0"/>
+          </a:p>
+        </p:txBody>
+      </p:sp>
+      <p:sp>
+        <p:nvSpPr>
+          <p:cNvPr id="8" name="Step 2 marker"/>
+          <p:cNvSpPr/>
+          <p:nvPr/>
+        </p:nvSpPr>
+        <p:spPr>
+          <a:xfrm>
+            <a:off x="8503920" y="2395728"/>
+            <a:ext cx="347472" cy="347472"/>
+          </a:xfrm>
+          <a:prstGeom prst="ellipse">
+            <a:avLst/>
+          </a:prstGeom>
+          <a:solidFill>
+            <a:schemeClr val="accent3"/>
+          </a:solidFill>
+          <a:ln w="12700">
+            <a:solidFill>
+              <a:schemeClr val="accent3"/>
+            </a:solidFill>
+            <a:prstDash val="solid"/>
+          </a:ln>
+        </p:spPr>
+      </p:sp>
+      <p:sp>
+        <p:nvSpPr>
+          <p:cNvPr id="9" name="Step 2 number"/>
+          <p:cNvSpPr txBox="1"/>
+          <p:nvPr/>
+        </p:nvSpPr>
+        <p:spPr>
+          <a:xfrm>
+            <a:off x="8503920" y="2395728"/>
+            <a:ext cx="347472" cy="347472"/>
+          </a:xfrm>
+          <a:prstGeom prst="rect">
+            <a:avLst/>
+          </a:prstGeom>
+          <a:noFill/>
+          <a:ln/>
+        </p:spPr>
+        <p:txBody>
+          <a:bodyPr wrap="square" lIns="0" tIns="0" rIns="0" bIns="0" rtlCol="0" anchor="ctr"/>
+          <a:lstStyle/>
+          <a:p>
+            <a:pPr algn="ctr" indent="0" marL="0">
+              <a:buNone/>
+            </a:pPr>
+            <a:r>
+              <a:rPr lang="en-US" sz="1300" b="1" dirty="0">
+                <a:solidFill>
+                  <a:schemeClr val="bg1"/>
+                </a:solidFill>
+              </a:rPr>
+              <a:t>2</a:t>
+            </a:r>
+            <a:endParaRPr lang="en-US" sz="1300" dirty="0"/>
+          </a:p>
+        </p:txBody>
+      </p:sp>
+      <p:sp>
+        <p:nvSpPr>
+          <p:cNvPr id="10" name="Step 2 text"/>
+          <p:cNvSpPr txBox="1"/>
+          <p:nvPr/>
+        </p:nvSpPr>
+        <p:spPr>
+          <a:xfrm>
+            <a:off x="8979408" y="2377440"/>
+            <a:ext cx="2770632" cy="1115568"/>
+          </a:xfrm>
+          <a:prstGeom prst="rect">
+            <a:avLst/>
+          </a:prstGeom>
+          <a:noFill/>
+          <a:ln/>
+        </p:spPr>
+        <p:txBody>
+          <a:bodyPr wrap="square" lIns="0" tIns="0" rIns="0" bIns="0" rtlCol="0" anchor="t"/>
+          <a:lstStyle/>
+          <a:p>
+            <a:pPr indent="0" marL="0">
+              <a:buNone/>
+            </a:pPr>
+            <a:r>
+              <a:rPr lang="en-US" sz="1350" dirty="0">
+                <a:solidFill>
+                  <a:schemeClr val="tx1"/>
+                </a:solidFill>
+              </a:rPr>
+              <a:t>Access for colleagues and password help.</a:t>
+            </a:r>
+            <a:endParaRPr lang="en-US" sz="1350" dirty="0"/>
+          </a:p>
+        </p:txBody>
+      </p:sp>
+      <p:sp>
+        <p:nvSpPr>
+          <p:cNvPr id="25" name="Slide Number Placeholder 0"/>
+          <p:cNvSpPr>
+            <a:spLocks noGrp="1"/>
+          </p:cNvSpPr>
+          <p:nvPr>
+            <p:ph type="sldNum" sz="quarter" idx="4294967295"/>
+          </p:nvPr>
+        </p:nvSpPr>
+        <p:spPr>
+          <a:xfrm>
+            <a:off x="11201400" y="6446520"/>
+            <a:ext cx="548640" cy="274320"/>
+          </a:xfrm>
+          <a:prstGeom prst="rect">
+            <a:avLst/>
+          </a:prstGeom>
+          <a:extLst>
+            <a:ext uri="{C572A759-6A51-4108-AA02-DFA0A04FC94B}">
+              <ma14:wrappingTextBoxFlag xmlns:ma14="http://schemas.microsoft.com/office/mac/drawingml/2011/main" val="0"/>
+            </a:ext>
+          </a:extLst>
+        </p:spPr>
+        <p:txBody>
+          <a:bodyPr/>
+          <a:lstStyle>
+            <a:lvl1pPr>
+              <a:defRPr sz="1000">
+                <a:solidFill>
+                  <a:srgbClr val="6B6E72"/>
+                </a:solidFill>
+              </a:defRPr>
+            </a:lvl1pPr>
+          </a:lstStyle>
+          <a:p>
+            <a:pPr algn="r"/>
+            <a:fld id="{F7021451-1387-4CA6-816F-3879F97B5CBC}" type="slidenum">
+              <a:rPr b="0" lang="en-US"/>
+              <a:t>21</a:t>
+            </a:fld>
+            <a:endParaRPr lang="en-US"/>
+          </a:p>
+        </p:txBody>
+      </p:sp>
+    </p:spTree>
+  </p:cSld>
+  <p:clrMapOvr>
+    <a:masterClrMapping/>
+  </p:clrMapOvr>
+</p:sld>
+</file>
+
+<file path=ppt/slides/slide22.xml><?xml version="1.0" encoding="utf-8"?>
+<p:sld xmlns:a="http://schemas.openxmlformats.org/drawingml/2006/main" xmlns:r="http://schemas.openxmlformats.org/officeDocument/2006/relationships" xmlns:p="http://schemas.openxmlformats.org/presentationml/2006/main">
+  <p:cSld name="Slide 22">
+    <p:spTree>
+      <p:nvGrpSpPr>
+        <p:cNvPr id="1" name=""/>
+        <p:cNvGrpSpPr/>
+        <p:nvPr/>
+      </p:nvGrpSpPr>
+      <p:grpSpPr>
+        <a:xfrm>
+          <a:off x="0" y="0"/>
+          <a:ext cx="0" cy="0"/>
+          <a:chOff x="0" y="0"/>
+          <a:chExt cx="0" cy="0"/>
+        </a:xfrm>
+      </p:grpSpPr>
+      <p:sp>
+        <p:nvSpPr>
+          <p:cNvPr id="2" name="Text 0"/>
+          <p:cNvSpPr/>
+          <p:nvPr>
+            <p:ph idx="101" type="title" hasCustomPrompt="1"/>
+          </p:nvPr>
+        </p:nvSpPr>
+        <p:spPr>
+          <a:xfrm>
+            <a:off x="457200" y="274320"/>
+            <a:ext cx="10058400" cy="685800"/>
+          </a:xfrm>
+          <a:prstGeom prst="rect">
+            <a:avLst/>
+          </a:prstGeom>
+          <a:noFill/>
+          <a:ln/>
+        </p:spPr>
+        <p:txBody>
+          <a:bodyPr wrap="square" lIns="0" tIns="0" rIns="0" bIns="0" rtlCol="0" anchor="ctr"/>
+          <a:lstStyle/>
+          <a:p>
+            <a:pPr algn="l" indent="0" marL="0">
+              <a:buNone/>
+            </a:pPr>
+            <a:r>
+              <a:rPr lang="en-US" sz="2800" b="1" dirty="0">
+                <a:solidFill>
+                  <a:schemeClr val="tx2"/>
+                </a:solidFill>
+              </a:rPr>
+              <a:t>We're here to help</a:t>
+            </a:r>
+            <a:endParaRPr lang="en-US" sz="2800" dirty="0"/>
+          </a:p>
+        </p:txBody>
+      </p:sp>
+      <p:sp>
+        <p:nvSpPr>
+          <p:cNvPr id="3" name="Point 1"/>
+          <p:cNvSpPr/>
+          <p:nvPr/>
+        </p:nvSpPr>
+        <p:spPr>
+          <a:xfrm>
+            <a:off x="457200" y="1417320"/>
+            <a:ext cx="11247120" cy="960120"/>
+          </a:xfrm>
+          <a:prstGeom prst="roundRect">
+            <a:avLst>
+              <a:gd name="adj" fmla="val 7619"/>
+            </a:avLst>
+          </a:prstGeom>
+          <a:solidFill>
+            <a:schemeClr val="bg1"/>
+          </a:solidFill>
+          <a:ln w="12700">
+            <a:solidFill>
+              <a:srgbClr val="DDE7E5"/>
+            </a:solidFill>
+            <a:prstDash val="solid"/>
+          </a:ln>
+        </p:spPr>
+      </p:sp>
+      <p:sp>
+        <p:nvSpPr>
+          <p:cNvPr id="4" name="Point 1 marker"/>
+          <p:cNvSpPr/>
+          <p:nvPr/>
+        </p:nvSpPr>
+        <p:spPr>
+          <a:xfrm>
+            <a:off x="731520" y="1668780"/>
+            <a:ext cx="457200" cy="457200"/>
+          </a:xfrm>
+          <a:prstGeom prst="ellipse">
+            <a:avLst/>
+          </a:prstGeom>
+          <a:solidFill>
+            <a:schemeClr val="accent2"/>
+          </a:solidFill>
+          <a:ln w="12700">
+            <a:solidFill>
+              <a:schemeClr val="accent2"/>
+            </a:solidFill>
+            <a:prstDash val="solid"/>
+          </a:ln>
+        </p:spPr>
+      </p:sp>
+      <p:sp>
+        <p:nvSpPr>
+          <p:cNvPr id="5" name="Point 1 tick"/>
+          <p:cNvSpPr txBox="1"/>
+          <p:nvPr/>
+        </p:nvSpPr>
+        <p:spPr>
+          <a:xfrm>
+            <a:off x="731520" y="1668780"/>
+            <a:ext cx="457200" cy="457200"/>
+          </a:xfrm>
+          <a:prstGeom prst="rect">
+            <a:avLst/>
+          </a:prstGeom>
+          <a:noFill/>
+          <a:ln/>
+        </p:spPr>
+        <p:txBody>
+          <a:bodyPr wrap="square" lIns="0" tIns="0" rIns="0" bIns="0" rtlCol="0" anchor="ctr"/>
+          <a:lstStyle/>
+          <a:p>
+            <a:pPr algn="ctr" indent="0" marL="0">
+              <a:buNone/>
+            </a:pPr>
+            <a:r>
+              <a:rPr lang="en-US" sz="1600" b="1" dirty="0">
+                <a:solidFill>
+                  <a:schemeClr val="bg1"/>
+                </a:solidFill>
+              </a:rPr>
+              <a:t>✓</a:t>
+            </a:r>
+            <a:endParaRPr lang="en-US" sz="1600" dirty="0"/>
+          </a:p>
+        </p:txBody>
+      </p:sp>
+      <p:sp>
+        <p:nvSpPr>
+          <p:cNvPr id="6" name="Point 1 text"/>
+          <p:cNvSpPr txBox="1"/>
+          <p:nvPr/>
+        </p:nvSpPr>
+        <p:spPr>
+          <a:xfrm>
+            <a:off x="1463040" y="1417320"/>
+            <a:ext cx="9966960" cy="960120"/>
+          </a:xfrm>
+          <a:prstGeom prst="rect">
+            <a:avLst/>
+          </a:prstGeom>
+          <a:noFill/>
+          <a:ln/>
+        </p:spPr>
+        <p:txBody>
+          <a:bodyPr wrap="square" lIns="0" tIns="0" rIns="0" bIns="0" rtlCol="0" anchor="ctr"/>
+          <a:lstStyle/>
+          <a:p>
+            <a:pPr indent="0" marL="0">
+              <a:buNone/>
+            </a:pPr>
+            <a:r>
+              <a:rPr lang="en-US" sz="1800" dirty="0">
+                <a:solidFill>
+                  <a:schemeClr val="tx1"/>
+                </a:solidFill>
+              </a:rPr>
+              <a:t>Call us on 0800 003 545.</a:t>
+            </a:r>
+            <a:endParaRPr lang="en-US" sz="1800" dirty="0"/>
+          </a:p>
+        </p:txBody>
+      </p:sp>
+      <p:sp>
+        <p:nvSpPr>
+          <p:cNvPr id="7" name="Point 2"/>
+          <p:cNvSpPr/>
+          <p:nvPr/>
+        </p:nvSpPr>
+        <p:spPr>
+          <a:xfrm>
+            <a:off x="457200" y="2560320"/>
+            <a:ext cx="11247120" cy="960120"/>
+          </a:xfrm>
+          <a:prstGeom prst="roundRect">
+            <a:avLst>
+              <a:gd name="adj" fmla="val 7619"/>
+            </a:avLst>
+          </a:prstGeom>
+          <a:solidFill>
+            <a:schemeClr val="bg1"/>
+          </a:solidFill>
+          <a:ln w="12700">
+            <a:solidFill>
+              <a:srgbClr val="DDE7E5"/>
+            </a:solidFill>
+            <a:prstDash val="solid"/>
+          </a:ln>
+        </p:spPr>
+      </p:sp>
+      <p:sp>
+        <p:nvSpPr>
+          <p:cNvPr id="8" name="Point 2 marker"/>
+          <p:cNvSpPr/>
+          <p:nvPr/>
+        </p:nvSpPr>
+        <p:spPr>
+          <a:xfrm>
+            <a:off x="731520" y="2811780"/>
+            <a:ext cx="457200" cy="457200"/>
+          </a:xfrm>
+          <a:prstGeom prst="ellipse">
+            <a:avLst/>
+          </a:prstGeom>
+          <a:solidFill>
+            <a:schemeClr val="accent2"/>
+          </a:solidFill>
+          <a:ln w="12700">
+            <a:solidFill>
+              <a:schemeClr val="accent2"/>
+            </a:solidFill>
+            <a:prstDash val="solid"/>
+          </a:ln>
+        </p:spPr>
+      </p:sp>
+      <p:sp>
+        <p:nvSpPr>
+          <p:cNvPr id="9" name="Point 2 tick"/>
+          <p:cNvSpPr txBox="1"/>
+          <p:nvPr/>
+        </p:nvSpPr>
+        <p:spPr>
+          <a:xfrm>
+            <a:off x="731520" y="2811780"/>
+            <a:ext cx="457200" cy="457200"/>
+          </a:xfrm>
+          <a:prstGeom prst="rect">
+            <a:avLst/>
+          </a:prstGeom>
+          <a:noFill/>
+          <a:ln/>
+        </p:spPr>
+        <p:txBody>
+          <a:bodyPr wrap="square" lIns="0" tIns="0" rIns="0" bIns="0" rtlCol="0" anchor="ctr"/>
+          <a:lstStyle/>
+          <a:p>
+            <a:pPr algn="ctr" indent="0" marL="0">
+              <a:buNone/>
+            </a:pPr>
+            <a:r>
+              <a:rPr lang="en-US" sz="1600" b="1" dirty="0">
+                <a:solidFill>
+                  <a:schemeClr val="bg1"/>
+                </a:solidFill>
+              </a:rPr>
+              <a:t>✓</a:t>
+            </a:r>
+            <a:endParaRPr lang="en-US" sz="1600" dirty="0"/>
+          </a:p>
+        </p:txBody>
+      </p:sp>
+      <p:sp>
+        <p:nvSpPr>
+          <p:cNvPr id="10" name="Point 2 text"/>
+          <p:cNvSpPr txBox="1"/>
+          <p:nvPr/>
+        </p:nvSpPr>
+        <p:spPr>
+          <a:xfrm>
+            <a:off x="1463040" y="2560320"/>
+            <a:ext cx="9966960" cy="960120"/>
+          </a:xfrm>
+          <a:prstGeom prst="rect">
+            <a:avLst/>
+          </a:prstGeom>
+          <a:noFill/>
+          <a:ln/>
+        </p:spPr>
+        <p:txBody>
+          <a:bodyPr wrap="square" lIns="0" tIns="0" rIns="0" bIns="0" rtlCol="0" anchor="ctr"/>
+          <a:lstStyle/>
+          <a:p>
+            <a:pPr indent="0" marL="0">
+              <a:buNone/>
+            </a:pPr>
+            <a:r>
+              <a:rPr lang="en-US" sz="1800" dirty="0">
+                <a:solidFill>
+                  <a:schemeClr val="tx1"/>
+                </a:solidFill>
+              </a:rPr>
+              <a:t>Email hello@ottainsurance.co.nz, or the team listed under Help &amp; contact.</a:t>
+            </a:r>
+            <a:endParaRPr lang="en-US" sz="1800" dirty="0"/>
+          </a:p>
+        </p:txBody>
+      </p:sp>
+      <p:sp>
+        <p:nvSpPr>
+          <p:cNvPr id="11" name="Point 3"/>
+          <p:cNvSpPr/>
+          <p:nvPr/>
+        </p:nvSpPr>
+        <p:spPr>
+          <a:xfrm>
+            <a:off x="457200" y="3703320"/>
+            <a:ext cx="11247120" cy="960120"/>
+          </a:xfrm>
+          <a:prstGeom prst="roundRect">
+            <a:avLst>
+              <a:gd name="adj" fmla="val 7619"/>
+            </a:avLst>
+          </a:prstGeom>
+          <a:solidFill>
+            <a:schemeClr val="bg1"/>
+          </a:solidFill>
+          <a:ln w="12700">
+            <a:solidFill>
+              <a:srgbClr val="DDE7E5"/>
+            </a:solidFill>
+            <a:prstDash val="solid"/>
+          </a:ln>
+        </p:spPr>
+      </p:sp>
+      <p:sp>
+        <p:nvSpPr>
+          <p:cNvPr id="12" name="Point 3 marker"/>
+          <p:cNvSpPr/>
+          <p:nvPr/>
+        </p:nvSpPr>
+        <p:spPr>
+          <a:xfrm>
+            <a:off x="731520" y="3954780"/>
+            <a:ext cx="457200" cy="457200"/>
+          </a:xfrm>
+          <a:prstGeom prst="ellipse">
+            <a:avLst/>
+          </a:prstGeom>
+          <a:solidFill>
+            <a:schemeClr val="accent2"/>
+          </a:solidFill>
+          <a:ln w="12700">
+            <a:solidFill>
+              <a:schemeClr val="accent2"/>
+            </a:solidFill>
+            <a:prstDash val="solid"/>
+          </a:ln>
+        </p:spPr>
+      </p:sp>
+      <p:sp>
+        <p:nvSpPr>
+          <p:cNvPr id="13" name="Point 3 tick"/>
+          <p:cNvSpPr txBox="1"/>
+          <p:nvPr/>
+        </p:nvSpPr>
+        <p:spPr>
+          <a:xfrm>
+            <a:off x="731520" y="3954780"/>
+            <a:ext cx="457200" cy="457200"/>
+          </a:xfrm>
+          <a:prstGeom prst="rect">
+            <a:avLst/>
+          </a:prstGeom>
+          <a:noFill/>
+          <a:ln/>
+        </p:spPr>
+        <p:txBody>
+          <a:bodyPr wrap="square" lIns="0" tIns="0" rIns="0" bIns="0" rtlCol="0" anchor="ctr"/>
+          <a:lstStyle/>
+          <a:p>
+            <a:pPr algn="ctr" indent="0" marL="0">
+              <a:buNone/>
+            </a:pPr>
+            <a:r>
+              <a:rPr lang="en-US" sz="1600" b="1" dirty="0">
+                <a:solidFill>
+                  <a:schemeClr val="bg1"/>
+                </a:solidFill>
+              </a:rPr>
+              <a:t>✓</a:t>
+            </a:r>
+            <a:endParaRPr lang="en-US" sz="1600" dirty="0"/>
+          </a:p>
+        </p:txBody>
+      </p:sp>
+      <p:sp>
+        <p:nvSpPr>
+          <p:cNvPr id="14" name="Point 3 text"/>
+          <p:cNvSpPr txBox="1"/>
+          <p:nvPr/>
+        </p:nvSpPr>
+        <p:spPr>
+          <a:xfrm>
+            <a:off x="1463040" y="3703320"/>
+            <a:ext cx="9966960" cy="960120"/>
+          </a:xfrm>
+          <a:prstGeom prst="rect">
+            <a:avLst/>
+          </a:prstGeom>
+          <a:noFill/>
+          <a:ln/>
+        </p:spPr>
+        <p:txBody>
+          <a:bodyPr wrap="square" lIns="0" tIns="0" rIns="0" bIns="0" rtlCol="0" anchor="ctr"/>
+          <a:lstStyle/>
+          <a:p>
+            <a:pPr indent="0" marL="0">
+              <a:buNone/>
+            </a:pPr>
+            <a:r>
+              <a:rPr lang="en-US" sz="1800" dirty="0">
+                <a:solidFill>
+                  <a:schemeClr val="tx1"/>
+                </a:solidFill>
+              </a:rPr>
+              <a:t>Claims: claims@ottainsurance.co.nz.</a:t>
+            </a:r>
+            <a:endParaRPr lang="en-US" sz="1800" dirty="0"/>
+          </a:p>
+        </p:txBody>
+      </p:sp>
+      <p:sp>
+        <p:nvSpPr>
+          <p:cNvPr id="15" name="Point 4"/>
+          <p:cNvSpPr/>
+          <p:nvPr/>
+        </p:nvSpPr>
+        <p:spPr>
+          <a:xfrm>
+            <a:off x="457200" y="4846320"/>
+            <a:ext cx="11247120" cy="960120"/>
+          </a:xfrm>
+          <a:prstGeom prst="roundRect">
+            <a:avLst>
+              <a:gd name="adj" fmla="val 7619"/>
+            </a:avLst>
+          </a:prstGeom>
+          <a:solidFill>
+            <a:schemeClr val="bg1"/>
+          </a:solidFill>
+          <a:ln w="12700">
+            <a:solidFill>
+              <a:srgbClr val="DDE7E5"/>
+            </a:solidFill>
+            <a:prstDash val="solid"/>
+          </a:ln>
+        </p:spPr>
+      </p:sp>
+      <p:sp>
+        <p:nvSpPr>
+          <p:cNvPr id="16" name="Point 4 marker"/>
+          <p:cNvSpPr/>
+          <p:nvPr/>
+        </p:nvSpPr>
+        <p:spPr>
+          <a:xfrm>
+            <a:off x="731520" y="5097780"/>
+            <a:ext cx="457200" cy="457200"/>
+          </a:xfrm>
+          <a:prstGeom prst="ellipse">
+            <a:avLst/>
+          </a:prstGeom>
+          <a:solidFill>
+            <a:schemeClr val="accent2"/>
+          </a:solidFill>
+          <a:ln w="12700">
+            <a:solidFill>
+              <a:schemeClr val="accent2"/>
+            </a:solidFill>
+            <a:prstDash val="solid"/>
+          </a:ln>
+        </p:spPr>
+      </p:sp>
+      <p:sp>
+        <p:nvSpPr>
+          <p:cNvPr id="17" name="Point 4 tick"/>
+          <p:cNvSpPr txBox="1"/>
+          <p:nvPr/>
+        </p:nvSpPr>
+        <p:spPr>
+          <a:xfrm>
+            <a:off x="731520" y="5097780"/>
+            <a:ext cx="457200" cy="457200"/>
+          </a:xfrm>
+          <a:prstGeom prst="rect">
+            <a:avLst/>
+          </a:prstGeom>
+          <a:noFill/>
+          <a:ln/>
+        </p:spPr>
+        <p:txBody>
+          <a:bodyPr wrap="square" lIns="0" tIns="0" rIns="0" bIns="0" rtlCol="0" anchor="ctr"/>
+          <a:lstStyle/>
+          <a:p>
+            <a:pPr algn="ctr" indent="0" marL="0">
+              <a:buNone/>
+            </a:pPr>
+            <a:r>
+              <a:rPr lang="en-US" sz="1600" b="1" dirty="0">
+                <a:solidFill>
+                  <a:schemeClr val="bg1"/>
+                </a:solidFill>
+              </a:rPr>
+              <a:t>✓</a:t>
+            </a:r>
+            <a:endParaRPr lang="en-US" sz="1600" dirty="0"/>
+          </a:p>
+        </p:txBody>
+      </p:sp>
+      <p:sp>
+        <p:nvSpPr>
+          <p:cNvPr id="18" name="Point 4 text"/>
+          <p:cNvSpPr txBox="1"/>
+          <p:nvPr/>
+        </p:nvSpPr>
+        <p:spPr>
+          <a:xfrm>
+            <a:off x="1463040" y="4846320"/>
+            <a:ext cx="9966960" cy="960120"/>
+          </a:xfrm>
+          <a:prstGeom prst="rect">
+            <a:avLst/>
+          </a:prstGeom>
+          <a:noFill/>
+          <a:ln/>
+        </p:spPr>
+        <p:txBody>
+          <a:bodyPr wrap="square" lIns="0" tIns="0" rIns="0" bIns="0" rtlCol="0" anchor="ctr"/>
+          <a:lstStyle/>
+          <a:p>
+            <a:pPr indent="0" marL="0">
+              <a:buNone/>
+            </a:pPr>
+            <a:r>
+              <a:rPr lang="en-US" sz="1800" dirty="0">
+                <a:solidFill>
+                  <a:schemeClr val="tx1"/>
+                </a:solidFill>
+              </a:rPr>
+              <a:t>Thanks for choosing Otta. We look forward to working with you.</a:t>
+            </a:r>
+            <a:endParaRPr lang="en-US" sz="1800" dirty="0"/>
+          </a:p>
+        </p:txBody>
+      </p:sp>
+      <p:sp>
+        <p:nvSpPr>
+          <p:cNvPr id="25" name="Slide Number Placeholder 0"/>
+          <p:cNvSpPr>
+            <a:spLocks noGrp="1"/>
+          </p:cNvSpPr>
+          <p:nvPr>
+            <p:ph type="sldNum" sz="quarter" idx="4294967295"/>
+          </p:nvPr>
+        </p:nvSpPr>
+        <p:spPr>
+          <a:xfrm>
+            <a:off x="11201400" y="6446520"/>
+            <a:ext cx="548640" cy="274320"/>
+          </a:xfrm>
+          <a:prstGeom prst="rect">
+            <a:avLst/>
+          </a:prstGeom>
+          <a:extLst>
+            <a:ext uri="{C572A759-6A51-4108-AA02-DFA0A04FC94B}">
+              <ma14:wrappingTextBoxFlag xmlns:ma14="http://schemas.microsoft.com/office/mac/drawingml/2011/main" val="0"/>
+            </a:ext>
+          </a:extLst>
+        </p:spPr>
+        <p:txBody>
+          <a:bodyPr/>
+          <a:lstStyle>
+            <a:lvl1pPr>
+              <a:defRPr sz="1000">
+                <a:solidFill>
+                  <a:srgbClr val="6B6E72"/>
+                </a:solidFill>
+              </a:defRPr>
+            </a:lvl1pPr>
+          </a:lstStyle>
+          <a:p>
+            <a:pPr algn="r"/>
+            <a:fld id="{F7021451-1387-4CA6-816F-3879F97B5CBC}" type="slidenum">
+              <a:rPr b="0" lang="en-US"/>
+              <a:t>22</a:t>
             </a:fld>
             <a:endParaRPr lang="en-US"/>
           </a:p>
@@ -10301,7 +11839,7 @@
                   <a:schemeClr val="tx1"/>
                 </a:solidFill>
               </a:rPr>
-              <a:t>Your open quote requests, active policies and renewals due.</a:t>
+              <a:t>Your active book: the annual premium of your clients' active policies with Otta.</a:t>
             </a:r>
             <a:endParaRPr lang="en-US" sz="1350" dirty="0"/>
           </a:p>
@@ -10398,7 +11936,7 @@
                   <a:schemeClr val="tx1"/>
                 </a:solidFill>
               </a:rPr>
-              <a:t>Shortcuts to proposal forms, renewal declarations, claim forms and general forms.</a:t>
+              <a:t>Your open quote requests, active policies and renewals due.</a:t>
             </a:r>
             <a:endParaRPr lang="en-US" sz="1350" dirty="0"/>
           </a:p>
@@ -10495,7 +12033,7 @@
                   <a:schemeClr val="tx1"/>
                 </a:solidFill>
               </a:rPr>
-              <a:t>Sign out when you're done.</a:t>
+              <a:t>Shortcuts to proposal forms, renewal declarations, claim forms and general forms.</a:t>
             </a:r>
             <a:endParaRPr lang="en-US" sz="1350" dirty="0"/>
           </a:p>
@@ -11326,7 +12864,7 @@
                   <a:schemeClr val="tx1"/>
                 </a:solidFill>
               </a:rPr>
-              <a:t>Or send it to your client.</a:t>
+              <a:t>Or create a secure link to send to your client.</a:t>
             </a:r>
             <a:endParaRPr lang="en-US" sz="1200" dirty="0"/>
           </a:p>

</xml_diff>